<commit_message>
Add 3 dataset pipeline slides: creation details, XML vs MXC example, engineering challenges
</commit_message>
<xml_diff>
--- a/examples/perception/optical_music_recognition/slides-omr-mxc/omr-mxc-results.pptx
+++ b/examples/perception/optical_music_recognition/slides-omr-mxc/omr-mxc-results.pptx
@@ -21,9 +21,12 @@
     <p:sldId id="269" r:id="rId15"/>
     <p:sldId id="270" r:id="rId16"/>
     <p:sldId id="271" r:id="rId17"/>
+    <p:sldId id="272" r:id="rId18"/>
+    <p:sldId id="273" r:id="rId19"/>
+    <p:sldId id="274" r:id="rId20"/>
   </p:sldIdLst>
   <p:notesMasterIdLst>
-    <p:notesMasterId r:id="rId18"/>
+    <p:notesMasterId r:id="rId21"/>
   </p:notesMasterIdLst>
   <p:sldSz cx="9144000" cy="5143500"/>
   <p:notesSz cx="5143500" cy="9144000"/>
@@ -1157,6 +1160,270 @@
             <a:fld id="{F7021451-1387-4CA6-816F-3879F97B5CBC}" type="slidenum">
               <a:rPr lang="en-US"/>
               <a:t>16</a:t>
+            </a:fld>
+            <a:endParaRPr lang="en-US"/>
+          </a:p>
+        </p:txBody>
+      </p:sp>
+    </p:spTree>
+    <p:extLst>
+      <p:ext uri="{BB962C8B-B14F-4D97-AF65-F5344CB8AC3E}">
+        <p14:creationId xmlns:p14="http://schemas.microsoft.com/office/powerpoint/2010/main" val="1024086991"/>
+      </p:ext>
+    </p:extLst>
+  </p:cSld>
+  <p:clrMapOvr>
+    <a:masterClrMapping/>
+  </p:clrMapOvr>
+</p:notes>
+</file>
+
+<file path=ppt/notesSlides/notesSlide17.xml><?xml version="1.0" encoding="utf-8"?>
+<p:notes xmlns:a="http://schemas.openxmlformats.org/drawingml/2006/main" xmlns:r="http://schemas.openxmlformats.org/officeDocument/2006/relationships" xmlns:p="http://schemas.openxmlformats.org/presentationml/2006/main">
+  <p:cSld>
+    <p:spTree>
+      <p:nvGrpSpPr>
+        <p:cNvPr id="1" name=""/>
+        <p:cNvGrpSpPr/>
+        <p:nvPr/>
+      </p:nvGrpSpPr>
+      <p:grpSpPr>
+        <a:xfrm>
+          <a:off x="0" y="0"/>
+          <a:ext cx="0" cy="0"/>
+          <a:chOff x="0" y="0"/>
+          <a:chExt cx="0" cy="0"/>
+        </a:xfrm>
+      </p:grpSpPr>
+      <p:sp>
+        <p:nvSpPr>
+          <p:cNvPr id="2" name="Slide Image Placeholder 1"/>
+          <p:cNvSpPr>
+            <a:spLocks noGrp="1" noRot="1" noChangeAspect="1"/>
+          </p:cNvSpPr>
+          <p:nvPr>
+            <p:ph type="sldImg"/>
+          </p:nvPr>
+        </p:nvSpPr>
+        <p:spPr/>
+      </p:sp>
+      <p:sp>
+        <p:nvSpPr>
+          <p:cNvPr id="3" name="Notes Placeholder 2"/>
+          <p:cNvSpPr>
+            <a:spLocks noGrp="1"/>
+          </p:cNvSpPr>
+          <p:nvPr>
+            <p:ph type="body" idx="1"/>
+          </p:nvPr>
+        </p:nvSpPr>
+        <p:spPr/>
+        <p:txBody>
+          <a:bodyPr/>
+          <a:lstStyle/>
+          <a:p>
+            <a:r>
+              <a:rPr lang="en-US" dirty="0"/>
+              <a:t/>
+            </a:r>
+            <a:endParaRPr lang="en-US" dirty="0"/>
+          </a:p>
+        </p:txBody>
+      </p:sp>
+      <p:sp>
+        <p:nvSpPr>
+          <p:cNvPr id="4" name="Slide Number Placeholder 3"/>
+          <p:cNvSpPr>
+            <a:spLocks noGrp="1"/>
+          </p:cNvSpPr>
+          <p:nvPr>
+            <p:ph type="sldNum" sz="quarter" idx="10"/>
+          </p:nvPr>
+        </p:nvSpPr>
+        <p:spPr/>
+        <p:txBody>
+          <a:bodyPr/>
+          <a:lstStyle/>
+          <a:p>
+            <a:fld id="{F7021451-1387-4CA6-816F-3879F97B5CBC}" type="slidenum">
+              <a:rPr lang="en-US"/>
+              <a:t>17</a:t>
+            </a:fld>
+            <a:endParaRPr lang="en-US"/>
+          </a:p>
+        </p:txBody>
+      </p:sp>
+    </p:spTree>
+    <p:extLst>
+      <p:ext uri="{BB962C8B-B14F-4D97-AF65-F5344CB8AC3E}">
+        <p14:creationId xmlns:p14="http://schemas.microsoft.com/office/powerpoint/2010/main" val="1024086991"/>
+      </p:ext>
+    </p:extLst>
+  </p:cSld>
+  <p:clrMapOvr>
+    <a:masterClrMapping/>
+  </p:clrMapOvr>
+</p:notes>
+</file>
+
+<file path=ppt/notesSlides/notesSlide18.xml><?xml version="1.0" encoding="utf-8"?>
+<p:notes xmlns:a="http://schemas.openxmlformats.org/drawingml/2006/main" xmlns:r="http://schemas.openxmlformats.org/officeDocument/2006/relationships" xmlns:p="http://schemas.openxmlformats.org/presentationml/2006/main">
+  <p:cSld>
+    <p:spTree>
+      <p:nvGrpSpPr>
+        <p:cNvPr id="1" name=""/>
+        <p:cNvGrpSpPr/>
+        <p:nvPr/>
+      </p:nvGrpSpPr>
+      <p:grpSpPr>
+        <a:xfrm>
+          <a:off x="0" y="0"/>
+          <a:ext cx="0" cy="0"/>
+          <a:chOff x="0" y="0"/>
+          <a:chExt cx="0" cy="0"/>
+        </a:xfrm>
+      </p:grpSpPr>
+      <p:sp>
+        <p:nvSpPr>
+          <p:cNvPr id="2" name="Slide Image Placeholder 1"/>
+          <p:cNvSpPr>
+            <a:spLocks noGrp="1" noRot="1" noChangeAspect="1"/>
+          </p:cNvSpPr>
+          <p:nvPr>
+            <p:ph type="sldImg"/>
+          </p:nvPr>
+        </p:nvSpPr>
+        <p:spPr/>
+      </p:sp>
+      <p:sp>
+        <p:nvSpPr>
+          <p:cNvPr id="3" name="Notes Placeholder 2"/>
+          <p:cNvSpPr>
+            <a:spLocks noGrp="1"/>
+          </p:cNvSpPr>
+          <p:nvPr>
+            <p:ph type="body" idx="1"/>
+          </p:nvPr>
+        </p:nvSpPr>
+        <p:spPr/>
+        <p:txBody>
+          <a:bodyPr/>
+          <a:lstStyle/>
+          <a:p>
+            <a:r>
+              <a:rPr lang="en-US" dirty="0"/>
+              <a:t/>
+            </a:r>
+            <a:endParaRPr lang="en-US" dirty="0"/>
+          </a:p>
+        </p:txBody>
+      </p:sp>
+      <p:sp>
+        <p:nvSpPr>
+          <p:cNvPr id="4" name="Slide Number Placeholder 3"/>
+          <p:cNvSpPr>
+            <a:spLocks noGrp="1"/>
+          </p:cNvSpPr>
+          <p:nvPr>
+            <p:ph type="sldNum" sz="quarter" idx="10"/>
+          </p:nvPr>
+        </p:nvSpPr>
+        <p:spPr/>
+        <p:txBody>
+          <a:bodyPr/>
+          <a:lstStyle/>
+          <a:p>
+            <a:fld id="{F7021451-1387-4CA6-816F-3879F97B5CBC}" type="slidenum">
+              <a:rPr lang="en-US"/>
+              <a:t>18</a:t>
+            </a:fld>
+            <a:endParaRPr lang="en-US"/>
+          </a:p>
+        </p:txBody>
+      </p:sp>
+    </p:spTree>
+    <p:extLst>
+      <p:ext uri="{BB962C8B-B14F-4D97-AF65-F5344CB8AC3E}">
+        <p14:creationId xmlns:p14="http://schemas.microsoft.com/office/powerpoint/2010/main" val="1024086991"/>
+      </p:ext>
+    </p:extLst>
+  </p:cSld>
+  <p:clrMapOvr>
+    <a:masterClrMapping/>
+  </p:clrMapOvr>
+</p:notes>
+</file>
+
+<file path=ppt/notesSlides/notesSlide19.xml><?xml version="1.0" encoding="utf-8"?>
+<p:notes xmlns:a="http://schemas.openxmlformats.org/drawingml/2006/main" xmlns:r="http://schemas.openxmlformats.org/officeDocument/2006/relationships" xmlns:p="http://schemas.openxmlformats.org/presentationml/2006/main">
+  <p:cSld>
+    <p:spTree>
+      <p:nvGrpSpPr>
+        <p:cNvPr id="1" name=""/>
+        <p:cNvGrpSpPr/>
+        <p:nvPr/>
+      </p:nvGrpSpPr>
+      <p:grpSpPr>
+        <a:xfrm>
+          <a:off x="0" y="0"/>
+          <a:ext cx="0" cy="0"/>
+          <a:chOff x="0" y="0"/>
+          <a:chExt cx="0" cy="0"/>
+        </a:xfrm>
+      </p:grpSpPr>
+      <p:sp>
+        <p:nvSpPr>
+          <p:cNvPr id="2" name="Slide Image Placeholder 1"/>
+          <p:cNvSpPr>
+            <a:spLocks noGrp="1" noRot="1" noChangeAspect="1"/>
+          </p:cNvSpPr>
+          <p:nvPr>
+            <p:ph type="sldImg"/>
+          </p:nvPr>
+        </p:nvSpPr>
+        <p:spPr/>
+      </p:sp>
+      <p:sp>
+        <p:nvSpPr>
+          <p:cNvPr id="3" name="Notes Placeholder 2"/>
+          <p:cNvSpPr>
+            <a:spLocks noGrp="1"/>
+          </p:cNvSpPr>
+          <p:nvPr>
+            <p:ph type="body" idx="1"/>
+          </p:nvPr>
+        </p:nvSpPr>
+        <p:spPr/>
+        <p:txBody>
+          <a:bodyPr/>
+          <a:lstStyle/>
+          <a:p>
+            <a:r>
+              <a:rPr lang="en-US" dirty="0"/>
+              <a:t/>
+            </a:r>
+            <a:endParaRPr lang="en-US" dirty="0"/>
+          </a:p>
+        </p:txBody>
+      </p:sp>
+      <p:sp>
+        <p:nvSpPr>
+          <p:cNvPr id="4" name="Slide Number Placeholder 3"/>
+          <p:cNvSpPr>
+            <a:spLocks noGrp="1"/>
+          </p:cNvSpPr>
+          <p:nvPr>
+            <p:ph type="sldNum" sz="quarter" idx="10"/>
+          </p:nvPr>
+        </p:nvSpPr>
+        <p:spPr/>
+        <p:txBody>
+          <a:bodyPr/>
+          <a:lstStyle/>
+          <a:p>
+            <a:fld id="{F7021451-1387-4CA6-816F-3879F97B5CBC}" type="slidenum">
+              <a:rPr lang="en-US"/>
+              <a:t>19</a:t>
             </a:fld>
             <a:endParaRPr lang="en-US"/>
           </a:p>
@@ -2428,7 +2695,7 @@
         <p:spPr>
           <a:xfrm>
             <a:off x="0" y="0"/>
-            <a:ext cx="9144000" cy="809625"/>
+            <a:ext cx="9144000" cy="781050"/>
           </a:xfrm>
           <a:prstGeom prst="rect">
             <a:avLst/>
@@ -2458,7 +2725,7 @@
         <p:spPr>
           <a:xfrm>
             <a:off x="381000" y="228600"/>
-            <a:ext cx="8549640" cy="352425"/>
+            <a:ext cx="8549640" cy="323850"/>
           </a:xfrm>
           <a:prstGeom prst="rect">
             <a:avLst/>
@@ -2474,7 +2741,7 @@
               <a:buNone/>
             </a:pPr>
             <a:r>
-              <a:rPr lang="en-US" sz="2400" b="1" dirty="0">
+              <a:rPr lang="en-US" sz="2200" b="1" dirty="0">
                 <a:solidFill>
                   <a:srgbClr val="FFFFFF"/>
                 </a:solidFill>
@@ -2482,15 +2749,708 @@
                 <a:ea typeface="Arial" pitchFamily="34" charset="-122"/>
                 <a:cs typeface="Arial" pitchFamily="34" charset="-120"/>
               </a:rPr>
-              <a:t>Model Comparison — MXC Targets</a:t>
-            </a:r>
-            <a:endParaRPr lang="en-US" sz="2400" dirty="0"/>
+              <a:t>Dataset Challenges and Scale</a:t>
+            </a:r>
+            <a:endParaRPr lang="en-US" sz="2200" dirty="0"/>
+          </a:p>
+        </p:txBody>
+      </p:sp>
+      <p:sp>
+        <p:nvSpPr>
+          <p:cNvPr id="4" name="Text 2"/>
+          <p:cNvSpPr/>
+          <p:nvPr/>
+        </p:nvSpPr>
+        <p:spPr>
+          <a:xfrm>
+            <a:off x="381000" y="908000"/>
+            <a:ext cx="4171137" cy="171450"/>
+          </a:xfrm>
+          <a:prstGeom prst="rect">
+            <a:avLst/>
+          </a:prstGeom>
+          <a:noFill/>
+          <a:ln/>
+        </p:spPr>
+        <p:txBody>
+          <a:bodyPr wrap="square" lIns="0" tIns="0" rIns="0" bIns="0" rtlCol="0" anchor="t"/>
+          <a:lstStyle/>
+          <a:p>
+            <a:pPr algn="l" indent="0" marL="0">
+              <a:spcAft>
+                <a:spcPts val="800"/>
+              </a:spcAft>
+              <a:buNone/>
+            </a:pPr>
+            <a:r>
+              <a:rPr lang="en-US" sz="1200" b="1" dirty="0">
+                <a:solidFill>
+                  <a:srgbClr val="E41159"/>
+                </a:solidFill>
+                <a:latin typeface="Arial" pitchFamily="34" charset="0"/>
+                <a:ea typeface="Arial" pitchFamily="34" charset="-122"/>
+                <a:cs typeface="Arial" pitchFamily="34" charset="-120"/>
+              </a:rPr>
+              <a:t>Engineering challenges</a:t>
+            </a:r>
+            <a:endParaRPr lang="en-US" sz="1200" dirty="0"/>
+          </a:p>
+        </p:txBody>
+      </p:sp>
+      <p:sp>
+        <p:nvSpPr>
+          <p:cNvPr id="5" name="Text 3"/>
+          <p:cNvSpPr/>
+          <p:nvPr/>
+        </p:nvSpPr>
+        <p:spPr>
+          <a:xfrm>
+            <a:off x="381000" y="1180951"/>
+            <a:ext cx="4089350" cy="1938635"/>
+          </a:xfrm>
+          <a:prstGeom prst="rect">
+            <a:avLst/>
+          </a:prstGeom>
+          <a:noFill/>
+          <a:ln/>
+        </p:spPr>
+        <p:txBody>
+          <a:bodyPr wrap="square" lIns="101600" tIns="0" rIns="0" bIns="0" rtlCol="0" anchor="t"/>
+          <a:lstStyle/>
+          <a:p>
+            <a:pPr algn="l" marL="101600" indent="-101600">
+              <a:lnSpc>
+                <a:spcPts val="1170"/>
+              </a:lnSpc>
+              <a:spcAft>
+                <a:spcPts val="600"/>
+              </a:spcAft>
+              <a:buSzPct val="100000"/>
+              <a:buChar char="•"/>
+            </a:pPr>
+            <a:r>
+              <a:rPr lang="en-US" sz="900" b="1" dirty="0">
+                <a:solidFill>
+                  <a:srgbClr val="110A29"/>
+                </a:solidFill>
+                <a:latin typeface="Arial" pitchFamily="34" charset="0"/>
+                <a:ea typeface="Arial" pitchFamily="34" charset="-122"/>
+                <a:cs typeface="Arial" pitchFamily="34" charset="-120"/>
+              </a:rPr>
+              <a:t>Render failures:</a:t>
+            </a:r>
+            <a:pPr algn="l" indent="0" marL="0">
+              <a:lnSpc>
+                <a:spcPts val="1170"/>
+              </a:lnSpc>
+              <a:spcAft>
+                <a:spcPts val="600"/>
+              </a:spcAft>
+              <a:buNone/>
+            </a:pPr>
+            <a:r>
+              <a:rPr lang="en-US" sz="900" dirty="0">
+                <a:solidFill>
+                  <a:srgbClr val="110A29"/>
+                </a:solidFill>
+                <a:latin typeface="Arial" pitchFamily="34" charset="0"/>
+                <a:ea typeface="Arial" pitchFamily="34" charset="-122"/>
+                <a:cs typeface="Arial" pitchFamily="34" charset="-120"/>
+              </a:rPr>
+              <a:t> 81/1,460 lieder, 4/122 quartets, 2/94 orchestra scores failed LilyPond rendering (syntax errors, zero-duration objects)</a:t>
+            </a:r>
+            <a:endParaRPr lang="en-US" sz="900" dirty="0"/>
+          </a:p>
+          <a:p>
+            <a:pPr algn="l" marL="101600" indent="-101600">
+              <a:lnSpc>
+                <a:spcPts val="1170"/>
+              </a:lnSpc>
+              <a:spcAft>
+                <a:spcPts val="600"/>
+              </a:spcAft>
+              <a:buSzPct val="100000"/>
+              <a:buChar char="•"/>
+            </a:pPr>
+            <a:r>
+              <a:rPr lang="en-US" sz="900" b="1" dirty="0">
+                <a:solidFill>
+                  <a:srgbClr val="110A29"/>
+                </a:solidFill>
+                <a:latin typeface="Arial" pitchFamily="34" charset="0"/>
+                <a:ea typeface="Arial" pitchFamily="34" charset="-122"/>
+                <a:cs typeface="Arial" pitchFamily="34" charset="-120"/>
+              </a:rPr>
+              <a:t>music21 slicing bugs:</a:t>
+            </a:r>
+            <a:pPr algn="l" indent="0" marL="0">
+              <a:lnSpc>
+                <a:spcPts val="1170"/>
+              </a:lnSpc>
+              <a:spcAft>
+                <a:spcPts val="600"/>
+              </a:spcAft>
+              <a:buNone/>
+            </a:pPr>
+            <a:r>
+              <a:rPr lang="en-US" sz="900" dirty="0">
+                <a:solidFill>
+                  <a:srgbClr val="110A29"/>
+                </a:solidFill>
+                <a:latin typeface="Arial" pitchFamily="34" charset="0"/>
+                <a:ea typeface="Arial" pitchFamily="34" charset="-122"/>
+                <a:cs typeface="Arial" pitchFamily="34" charset="-120"/>
+              </a:rPr>
+              <a:t> arpeggio spanners cause TypeError; retry with gatherSpanners=False. "Measure already in stream" on some page boundaries</a:t>
+            </a:r>
+            <a:endParaRPr lang="en-US" sz="900" dirty="0"/>
+          </a:p>
+          <a:p>
+            <a:pPr algn="l" marL="101600" indent="-101600">
+              <a:lnSpc>
+                <a:spcPts val="1170"/>
+              </a:lnSpc>
+              <a:spcAft>
+                <a:spcPts val="600"/>
+              </a:spcAft>
+              <a:buSzPct val="100000"/>
+              <a:buChar char="•"/>
+            </a:pPr>
+            <a:r>
+              <a:rPr lang="en-US" sz="900" b="1" dirty="0">
+                <a:solidFill>
+                  <a:srgbClr val="110A29"/>
+                </a:solidFill>
+                <a:latin typeface="Arial" pitchFamily="34" charset="0"/>
+                <a:ea typeface="Arial" pitchFamily="34" charset="-122"/>
+                <a:cs typeface="Arial" pitchFamily="34" charset="-120"/>
+              </a:rPr>
+              <a:t>SVG bar number parsing:</a:t>
+            </a:r>
+            <a:pPr algn="l" indent="0" marL="0">
+              <a:lnSpc>
+                <a:spcPts val="1170"/>
+              </a:lnSpc>
+              <a:spcAft>
+                <a:spcPts val="600"/>
+              </a:spcAft>
+              <a:buNone/>
+            </a:pPr>
+            <a:r>
+              <a:rPr lang="en-US" sz="900" dirty="0">
+                <a:solidFill>
+                  <a:srgbClr val="110A29"/>
+                </a:solidFill>
+                <a:latin typeface="Arial" pitchFamily="34" charset="0"/>
+                <a:ea typeface="Arial" pitchFamily="34" charset="-122"/>
+                <a:cs typeface="Arial" pitchFamily="34" charset="-120"/>
+              </a:rPr>
+              <a:t> time signature denominators have same font size as bar numbers; disambiguate by keeping largest consecutive-integer cluster</a:t>
+            </a:r>
+            <a:endParaRPr lang="en-US" sz="900" dirty="0"/>
+          </a:p>
+          <a:p>
+            <a:pPr algn="l" marL="101600" indent="-101600">
+              <a:lnSpc>
+                <a:spcPts val="1170"/>
+              </a:lnSpc>
+              <a:spcAft>
+                <a:spcPts val="600"/>
+              </a:spcAft>
+              <a:buSzPct val="100000"/>
+              <a:buChar char="•"/>
+            </a:pPr>
+            <a:r>
+              <a:rPr lang="en-US" sz="900" b="1" dirty="0">
+                <a:solidFill>
+                  <a:srgbClr val="110A29"/>
+                </a:solidFill>
+                <a:latin typeface="Arial" pitchFamily="34" charset="0"/>
+                <a:ea typeface="Arial" pitchFamily="34" charset="-122"/>
+                <a:cs typeface="Arial" pitchFamily="34" charset="-120"/>
+              </a:rPr>
+              <a:t>Pickup bars:</a:t>
+            </a:r>
+            <a:pPr algn="l" indent="0" marL="0">
+              <a:lnSpc>
+                <a:spcPts val="1170"/>
+              </a:lnSpc>
+              <a:spcAft>
+                <a:spcPts val="600"/>
+              </a:spcAft>
+              <a:buNone/>
+            </a:pPr>
+            <a:r>
+              <a:rPr lang="en-US" sz="900" dirty="0">
+                <a:solidFill>
+                  <a:srgbClr val="110A29"/>
+                </a:solidFill>
+                <a:latin typeface="Arial" pitchFamily="34" charset="0"/>
+                <a:ea typeface="Arial" pitchFamily="34" charset="-122"/>
+                <a:cs typeface="Arial" pitchFamily="34" charset="-120"/>
+              </a:rPr>
+              <a:t> 23% of lieder have measure 0; auto-detect and offset SVG bar numbers by -1</a:t>
+            </a:r>
+            <a:endParaRPr lang="en-US" sz="900" dirty="0"/>
+          </a:p>
+          <a:p>
+            <a:pPr algn="l" marL="101600" indent="-101600">
+              <a:lnSpc>
+                <a:spcPts val="1170"/>
+              </a:lnSpc>
+              <a:spcAft>
+                <a:spcPts val="600"/>
+              </a:spcAft>
+              <a:buSzPct val="100000"/>
+              <a:buChar char="•"/>
+            </a:pPr>
+            <a:r>
+              <a:rPr lang="en-US" sz="900" b="1" dirty="0">
+                <a:solidFill>
+                  <a:srgbClr val="110A29"/>
+                </a:solidFill>
+                <a:latin typeface="Arial" pitchFamily="34" charset="0"/>
+                <a:ea typeface="Arial" pitchFamily="34" charset="-122"/>
+                <a:cs typeface="Arial" pitchFamily="34" charset="-120"/>
+              </a:rPr>
+              <a:t>Runtime:</a:t>
+            </a:r>
+            <a:pPr algn="l" indent="0" marL="0">
+              <a:lnSpc>
+                <a:spcPts val="1170"/>
+              </a:lnSpc>
+              <a:spcAft>
+                <a:spcPts val="600"/>
+              </a:spcAft>
+              <a:buNone/>
+            </a:pPr>
+            <a:r>
+              <a:rPr lang="en-US" sz="900" dirty="0">
+                <a:solidFill>
+                  <a:srgbClr val="110A29"/>
+                </a:solidFill>
+                <a:latin typeface="Arial" pitchFamily="34" charset="0"/>
+                <a:ea typeface="Arial" pitchFamily="34" charset="-122"/>
+                <a:cs typeface="Arial" pitchFamily="34" charset="-120"/>
+              </a:rPr>
+              <a:t> 12-20 hours per corpus (Docker render + music21 slicing)</a:t>
+            </a:r>
+            <a:endParaRPr lang="en-US" sz="900" dirty="0"/>
+          </a:p>
+        </p:txBody>
+      </p:sp>
+      <p:sp>
+        <p:nvSpPr>
+          <p:cNvPr id="6" name="Text 4"/>
+          <p:cNvSpPr/>
+          <p:nvPr/>
+        </p:nvSpPr>
+        <p:spPr>
+          <a:xfrm>
+            <a:off x="4673501" y="908000"/>
+            <a:ext cx="4171289" cy="171450"/>
+          </a:xfrm>
+          <a:prstGeom prst="rect">
+            <a:avLst/>
+          </a:prstGeom>
+          <a:noFill/>
+          <a:ln/>
+        </p:spPr>
+        <p:txBody>
+          <a:bodyPr wrap="square" lIns="0" tIns="0" rIns="0" bIns="0" rtlCol="0" anchor="t"/>
+          <a:lstStyle/>
+          <a:p>
+            <a:pPr algn="l" indent="0" marL="0">
+              <a:spcAft>
+                <a:spcPts val="800"/>
+              </a:spcAft>
+              <a:buNone/>
+            </a:pPr>
+            <a:r>
+              <a:rPr lang="en-US" sz="1200" b="1" dirty="0">
+                <a:solidFill>
+                  <a:srgbClr val="E41159"/>
+                </a:solidFill>
+                <a:latin typeface="Arial" pitchFamily="34" charset="0"/>
+                <a:ea typeface="Arial" pitchFamily="34" charset="-122"/>
+                <a:cs typeface="Arial" pitchFamily="34" charset="-120"/>
+              </a:rPr>
+              <a:t>Final dataset stats</a:t>
+            </a:r>
+            <a:endParaRPr lang="en-US" sz="1200" dirty="0"/>
+          </a:p>
+        </p:txBody>
+      </p:sp>
+      <p:sp>
+        <p:nvSpPr>
+          <p:cNvPr id="7" name="Text 5"/>
+          <p:cNvSpPr/>
+          <p:nvPr/>
+        </p:nvSpPr>
+        <p:spPr>
+          <a:xfrm>
+            <a:off x="4673501" y="1180951"/>
+            <a:ext cx="4089499" cy="803077"/>
+          </a:xfrm>
+          <a:prstGeom prst="roundRect">
+            <a:avLst>
+              <a:gd name="adj" fmla="val 6326"/>
+            </a:avLst>
+          </a:prstGeom>
+          <a:solidFill>
+            <a:srgbClr val="F5F3F2"/>
+          </a:solidFill>
+          <a:ln w="9525">
+            <a:solidFill>
+              <a:srgbClr val="D9D5D2"/>
+            </a:solidFill>
+          </a:ln>
+        </p:spPr>
+        <p:txBody>
+          <a:bodyPr wrap="square" rtlCol="0" anchor="ctr"/>
+          <a:lstStyle/>
+          <a:p>
+            <a:pPr indent="0" marL="0">
+              <a:buNone/>
+            </a:pPr>
+            <a:endParaRPr lang="en-US" dirty="0"/>
+          </a:p>
+        </p:txBody>
+      </p:sp>
+      <p:sp>
+        <p:nvSpPr>
+          <p:cNvPr id="8" name="Text 6"/>
+          <p:cNvSpPr/>
+          <p:nvPr/>
+        </p:nvSpPr>
+        <p:spPr>
+          <a:xfrm>
+            <a:off x="4809976" y="1317427"/>
+            <a:ext cx="3892879" cy="142875"/>
+          </a:xfrm>
+          <a:prstGeom prst="rect">
+            <a:avLst/>
+          </a:prstGeom>
+          <a:noFill/>
+          <a:ln/>
+        </p:spPr>
+        <p:txBody>
+          <a:bodyPr wrap="square" lIns="0" tIns="0" rIns="0" bIns="0" rtlCol="0" anchor="t"/>
+          <a:lstStyle/>
+          <a:p>
+            <a:pPr algn="l" indent="0" marL="0">
+              <a:spcAft>
+                <a:spcPts val="400"/>
+              </a:spcAft>
+              <a:buNone/>
+            </a:pPr>
+            <a:r>
+              <a:rPr lang="en-US" sz="1000" b="1" dirty="0">
+                <a:solidFill>
+                  <a:srgbClr val="110A29"/>
+                </a:solidFill>
+                <a:latin typeface="Arial" pitchFamily="34" charset="0"/>
+                <a:ea typeface="Arial" pitchFamily="34" charset="-122"/>
+                <a:cs typeface="Arial" pitchFamily="34" charset="-120"/>
+              </a:rPr>
+              <a:t>Lieder:</a:t>
+            </a:r>
+            <a:pPr algn="l" indent="0" marL="0">
+              <a:spcAft>
+                <a:spcPts val="400"/>
+              </a:spcAft>
+              <a:buNone/>
+            </a:pPr>
+            <a:r>
+              <a:rPr lang="en-US" sz="1000" dirty="0">
+                <a:solidFill>
+                  <a:srgbClr val="110A29"/>
+                </a:solidFill>
+                <a:latin typeface="Arial" pitchFamily="34" charset="0"/>
+                <a:ea typeface="Arial" pitchFamily="34" charset="-122"/>
+                <a:cs typeface="Arial" pitchFamily="34" charset="-120"/>
+              </a:rPr>
+              <a:t> 3,312 train / 209 dev / 223 test</a:t>
+            </a:r>
+            <a:endParaRPr lang="en-US" sz="1000" dirty="0"/>
+          </a:p>
+        </p:txBody>
+      </p:sp>
+      <p:sp>
+        <p:nvSpPr>
+          <p:cNvPr id="9" name="Text 7"/>
+          <p:cNvSpPr/>
+          <p:nvPr/>
+        </p:nvSpPr>
+        <p:spPr>
+          <a:xfrm>
+            <a:off x="4809976" y="1511052"/>
+            <a:ext cx="3892879" cy="142875"/>
+          </a:xfrm>
+          <a:prstGeom prst="rect">
+            <a:avLst/>
+          </a:prstGeom>
+          <a:noFill/>
+          <a:ln/>
+        </p:spPr>
+        <p:txBody>
+          <a:bodyPr wrap="square" lIns="0" tIns="0" rIns="0" bIns="0" rtlCol="0" anchor="t"/>
+          <a:lstStyle/>
+          <a:p>
+            <a:pPr algn="l" indent="0" marL="0">
+              <a:spcAft>
+                <a:spcPts val="400"/>
+              </a:spcAft>
+              <a:buNone/>
+            </a:pPr>
+            <a:r>
+              <a:rPr lang="en-US" sz="1000" b="1" dirty="0">
+                <a:solidFill>
+                  <a:srgbClr val="110A29"/>
+                </a:solidFill>
+                <a:latin typeface="Arial" pitchFamily="34" charset="0"/>
+                <a:ea typeface="Arial" pitchFamily="34" charset="-122"/>
+                <a:cs typeface="Arial" pitchFamily="34" charset="-120"/>
+              </a:rPr>
+              <a:t>Quartets:</a:t>
+            </a:r>
+            <a:pPr algn="l" indent="0" marL="0">
+              <a:spcAft>
+                <a:spcPts val="400"/>
+              </a:spcAft>
+              <a:buNone/>
+            </a:pPr>
+            <a:r>
+              <a:rPr lang="en-US" sz="1000" dirty="0">
+                <a:solidFill>
+                  <a:srgbClr val="110A29"/>
+                </a:solidFill>
+                <a:latin typeface="Arial" pitchFamily="34" charset="0"/>
+                <a:ea typeface="Arial" pitchFamily="34" charset="-122"/>
+                <a:cs typeface="Arial" pitchFamily="34" charset="-120"/>
+              </a:rPr>
+              <a:t> 6,274 train / 136 dev</a:t>
+            </a:r>
+            <a:endParaRPr lang="en-US" sz="1000" dirty="0"/>
+          </a:p>
+        </p:txBody>
+      </p:sp>
+      <p:sp>
+        <p:nvSpPr>
+          <p:cNvPr id="10" name="Text 8"/>
+          <p:cNvSpPr/>
+          <p:nvPr/>
+        </p:nvSpPr>
+        <p:spPr>
+          <a:xfrm>
+            <a:off x="4809976" y="1704677"/>
+            <a:ext cx="3892879" cy="142875"/>
+          </a:xfrm>
+          <a:prstGeom prst="rect">
+            <a:avLst/>
+          </a:prstGeom>
+          <a:noFill/>
+          <a:ln/>
+        </p:spPr>
+        <p:txBody>
+          <a:bodyPr wrap="square" lIns="0" tIns="0" rIns="0" bIns="0" rtlCol="0" anchor="t"/>
+          <a:lstStyle/>
+          <a:p>
+            <a:pPr algn="l" indent="0" marL="0">
+              <a:buNone/>
+            </a:pPr>
+            <a:r>
+              <a:rPr lang="en-US" sz="1000" b="1" dirty="0">
+                <a:solidFill>
+                  <a:srgbClr val="110A29"/>
+                </a:solidFill>
+                <a:latin typeface="Arial" pitchFamily="34" charset="0"/>
+                <a:ea typeface="Arial" pitchFamily="34" charset="-122"/>
+                <a:cs typeface="Arial" pitchFamily="34" charset="-120"/>
+              </a:rPr>
+              <a:t>Orchestra:</a:t>
+            </a:r>
+            <a:pPr algn="l" indent="0" marL="0">
+              <a:buNone/>
+            </a:pPr>
+            <a:r>
+              <a:rPr lang="en-US" sz="1000" dirty="0">
+                <a:solidFill>
+                  <a:srgbClr val="110A29"/>
+                </a:solidFill>
+                <a:latin typeface="Arial" pitchFamily="34" charset="0"/>
+                <a:ea typeface="Arial" pitchFamily="34" charset="-122"/>
+                <a:cs typeface="Arial" pitchFamily="34" charset="-120"/>
+              </a:rPr>
+              <a:t> 4,870 train / 242 test</a:t>
+            </a:r>
+            <a:endParaRPr lang="en-US" sz="1000" dirty="0"/>
+          </a:p>
+        </p:txBody>
+      </p:sp>
+      <p:sp>
+        <p:nvSpPr>
+          <p:cNvPr id="11" name="Text 9"/>
+          <p:cNvSpPr/>
+          <p:nvPr/>
+        </p:nvSpPr>
+        <p:spPr>
+          <a:xfrm>
+            <a:off x="4673501" y="2085529"/>
+            <a:ext cx="4171289" cy="171450"/>
+          </a:xfrm>
+          <a:prstGeom prst="rect">
+            <a:avLst/>
+          </a:prstGeom>
+          <a:noFill/>
+          <a:ln/>
+        </p:spPr>
+        <p:txBody>
+          <a:bodyPr wrap="square" lIns="0" tIns="0" rIns="0" bIns="0" rtlCol="0" anchor="t"/>
+          <a:lstStyle/>
+          <a:p>
+            <a:pPr algn="l" indent="0" marL="0">
+              <a:spcAft>
+                <a:spcPts val="800"/>
+              </a:spcAft>
+              <a:buNone/>
+            </a:pPr>
+            <a:r>
+              <a:rPr lang="en-US" sz="1200" b="1" dirty="0">
+                <a:solidFill>
+                  <a:srgbClr val="E41159"/>
+                </a:solidFill>
+                <a:latin typeface="Arial" pitchFamily="34" charset="0"/>
+                <a:ea typeface="Arial" pitchFamily="34" charset="-122"/>
+                <a:cs typeface="Arial" pitchFamily="34" charset="-120"/>
+              </a:rPr>
+              <a:t>Data quality</a:t>
+            </a:r>
+            <a:endParaRPr lang="en-US" sz="1200" dirty="0"/>
+          </a:p>
+        </p:txBody>
+      </p:sp>
+      <p:sp>
+        <p:nvSpPr>
+          <p:cNvPr id="12" name="Text 10"/>
+          <p:cNvSpPr/>
+          <p:nvPr/>
+        </p:nvSpPr>
+        <p:spPr>
+          <a:xfrm>
+            <a:off x="4673501" y="2358479"/>
+            <a:ext cx="4089499" cy="822722"/>
+          </a:xfrm>
+          <a:prstGeom prst="rect">
+            <a:avLst/>
+          </a:prstGeom>
+          <a:noFill/>
+          <a:ln/>
+        </p:spPr>
+        <p:txBody>
+          <a:bodyPr wrap="square" lIns="101600" tIns="0" rIns="0" bIns="0" rtlCol="0" anchor="t"/>
+          <a:lstStyle/>
+          <a:p>
+            <a:pPr algn="l" marL="101600" indent="-101600">
+              <a:lnSpc>
+                <a:spcPts val="1170"/>
+              </a:lnSpc>
+              <a:spcAft>
+                <a:spcPts val="600"/>
+              </a:spcAft>
+              <a:buSzPct val="100000"/>
+              <a:buChar char="•"/>
+            </a:pPr>
+            <a:r>
+              <a:rPr lang="en-US" sz="900" dirty="0">
+                <a:solidFill>
+                  <a:srgbClr val="110A29"/>
+                </a:solidFill>
+                <a:latin typeface="Arial" pitchFamily="34" charset="0"/>
+                <a:ea typeface="Arial" pitchFamily="34" charset="-122"/>
+                <a:cs typeface="Arial" pitchFamily="34" charset="-120"/>
+              </a:rPr>
+              <a:t>3/500 lieder samples have malformed XML (music21 export bugs)</a:t>
+            </a:r>
+            <a:endParaRPr lang="en-US" sz="900" dirty="0"/>
+          </a:p>
+          <a:p>
+            <a:pPr algn="l" marL="101600" indent="-101600">
+              <a:lnSpc>
+                <a:spcPts val="1170"/>
+              </a:lnSpc>
+              <a:spcAft>
+                <a:spcPts val="600"/>
+              </a:spcAft>
+              <a:buSzPct val="100000"/>
+              <a:buChar char="•"/>
+            </a:pPr>
+            <a:r>
+              <a:rPr lang="en-US" sz="900" dirty="0">
+                <a:solidFill>
+                  <a:srgbClr val="110A29"/>
+                </a:solidFill>
+                <a:latin typeface="Arial" pitchFamily="34" charset="0"/>
+                <a:ea typeface="Arial" pitchFamily="34" charset="-122"/>
+                <a:cs typeface="Arial" pitchFamily="34" charset="-120"/>
+              </a:rPr>
+              <a:t>7/27,632 lyric elements contain non-breaking spaces</a:t>
+            </a:r>
+            <a:endParaRPr lang="en-US" sz="900" dirty="0"/>
+          </a:p>
+          <a:p>
+            <a:pPr algn="l" marL="101600" indent="-101600">
+              <a:lnSpc>
+                <a:spcPts val="1170"/>
+              </a:lnSpc>
+              <a:spcAft>
+                <a:spcPts val="600"/>
+              </a:spcAft>
+              <a:buSzPct val="100000"/>
+              <a:buChar char="•"/>
+            </a:pPr>
+            <a:r>
+              <a:rPr lang="en-US" sz="900" dirty="0">
+                <a:solidFill>
+                  <a:srgbClr val="110A29"/>
+                </a:solidFill>
+                <a:latin typeface="Arial" pitchFamily="34" charset="0"/>
+                <a:ea typeface="Arial" pitchFamily="34" charset="-122"/>
+                <a:cs typeface="Arial" pitchFamily="34" charset="-120"/>
+              </a:rPr>
+              <a:t>224 quartet pages skipped (page-number-only, no bar content)</a:t>
+            </a:r>
+            <a:endParaRPr lang="en-US" sz="900" dirty="0"/>
+          </a:p>
+          <a:p>
+            <a:pPr algn="l" marL="101600" indent="-101600">
+              <a:lnSpc>
+                <a:spcPts val="1170"/>
+              </a:lnSpc>
+              <a:spcAft>
+                <a:spcPts val="600"/>
+              </a:spcAft>
+              <a:buSzPct val="100000"/>
+              <a:buChar char="•"/>
+            </a:pPr>
+            <a:r>
+              <a:rPr lang="en-US" sz="900" dirty="0">
+                <a:solidFill>
+                  <a:srgbClr val="110A29"/>
+                </a:solidFill>
+                <a:latin typeface="Arial" pitchFamily="34" charset="0"/>
+                <a:ea typeface="Arial" pitchFamily="34" charset="-122"/>
+                <a:cs typeface="Arial" pitchFamily="34" charset="-120"/>
+              </a:rPr>
+              <a:t>All issues documented in page_musicxml_runs.md for future fixes</a:t>
+            </a:r>
+            <a:endParaRPr lang="en-US" sz="900" dirty="0"/>
           </a:p>
         </p:txBody>
       </p:sp>
       <p:pic>
         <p:nvPicPr>
-          <p:cNvPr id="4" name="Image 0" descr="/home/zsi/projects/worktrees/CVlization/vintage-music-sheet/examples/perception/optical_music_recognition/slides-omr-mxc/kungfu-logo.png">    </p:cNvPr>
+          <p:cNvPr id="13" name="Image 0" descr="/home/zsi/projects/worktrees/CVlization/vintage-music-sheet/examples/perception/optical_music_recognition/slides-omr-mxc/kungfu-logo.png">    </p:cNvPr>
           <p:cNvPicPr>
             <a:picLocks noChangeAspect="1"/>
           </p:cNvPicPr>
@@ -2512,9 +3472,1108 @@
           </a:prstGeom>
         </p:spPr>
       </p:pic>
+    </p:spTree>
+  </p:cSld>
+  <p:clrMapOvr>
+    <a:masterClrMapping/>
+  </p:clrMapOvr>
+</p:sld>
+</file>
+
+<file path=ppt/slides/slide11.xml><?xml version="1.0" encoding="utf-8"?>
+<p:sld xmlns:a="http://schemas.openxmlformats.org/drawingml/2006/main" xmlns:r="http://schemas.openxmlformats.org/officeDocument/2006/relationships" xmlns:p="http://schemas.openxmlformats.org/presentationml/2006/main">
+  <p:cSld name="Slide 11">
+    <p:bg>
+      <p:bgPr>
+        <a:solidFill>
+          <a:srgbClr val="FFFFFF"/>
+        </a:solidFill>
+      </p:bgPr>
+    </p:bg>
+    <p:spTree>
+      <p:nvGrpSpPr>
+        <p:cNvPr id="1" name=""/>
+        <p:cNvGrpSpPr/>
+        <p:nvPr/>
+      </p:nvGrpSpPr>
+      <p:grpSpPr>
+        <a:xfrm>
+          <a:off x="0" y="0"/>
+          <a:ext cx="0" cy="0"/>
+          <a:chOff x="0" y="0"/>
+          <a:chExt cx="0" cy="0"/>
+        </a:xfrm>
+      </p:grpSpPr>
+      <p:sp>
+        <p:nvSpPr>
+          <p:cNvPr id="2" name="Text 0"/>
+          <p:cNvSpPr/>
+          <p:nvPr/>
+        </p:nvSpPr>
+        <p:spPr>
+          <a:xfrm>
+            <a:off x="0" y="0"/>
+            <a:ext cx="9144000" cy="809625"/>
+          </a:xfrm>
+          <a:prstGeom prst="rect">
+            <a:avLst/>
+          </a:prstGeom>
+          <a:solidFill>
+            <a:srgbClr val="E41159"/>
+          </a:solidFill>
+          <a:ln/>
+        </p:spPr>
+        <p:txBody>
+          <a:bodyPr wrap="square" rtlCol="0" anchor="ctr"/>
+          <a:lstStyle/>
+          <a:p>
+            <a:pPr indent="0" marL="0">
+              <a:buNone/>
+            </a:pPr>
+            <a:endParaRPr lang="en-US" dirty="0"/>
+          </a:p>
+        </p:txBody>
+      </p:sp>
+      <p:sp>
+        <p:nvSpPr>
+          <p:cNvPr id="3" name="Text 1"/>
+          <p:cNvSpPr/>
+          <p:nvPr/>
+        </p:nvSpPr>
+        <p:spPr>
+          <a:xfrm>
+            <a:off x="381000" y="228600"/>
+            <a:ext cx="8549640" cy="352425"/>
+          </a:xfrm>
+          <a:prstGeom prst="rect">
+            <a:avLst/>
+          </a:prstGeom>
+          <a:noFill/>
+          <a:ln/>
+        </p:spPr>
+        <p:txBody>
+          <a:bodyPr wrap="square" lIns="0" tIns="0" rIns="0" bIns="0" rtlCol="0" anchor="t"/>
+          <a:lstStyle/>
+          <a:p>
+            <a:pPr algn="l" indent="0" marL="0">
+              <a:buNone/>
+            </a:pPr>
+            <a:r>
+              <a:rPr lang="en-US" sz="2400" b="1" dirty="0">
+                <a:solidFill>
+                  <a:srgbClr val="FFFFFF"/>
+                </a:solidFill>
+                <a:latin typeface="Arial" pitchFamily="34" charset="0"/>
+                <a:ea typeface="Arial" pitchFamily="34" charset="-122"/>
+                <a:cs typeface="Arial" pitchFamily="34" charset="-120"/>
+              </a:rPr>
+              <a:t>The Token Bottleneck</a:t>
+            </a:r>
+            <a:endParaRPr lang="en-US" sz="2400" dirty="0"/>
+          </a:p>
+        </p:txBody>
+      </p:sp>
+      <p:sp>
+        <p:nvSpPr>
+          <p:cNvPr id="4" name="Text 2"/>
+          <p:cNvSpPr/>
+          <p:nvPr/>
+        </p:nvSpPr>
+        <p:spPr>
+          <a:xfrm>
+            <a:off x="381000" y="962025"/>
+            <a:ext cx="4009314" cy="209550"/>
+          </a:xfrm>
+          <a:prstGeom prst="rect">
+            <a:avLst/>
+          </a:prstGeom>
+          <a:noFill/>
+          <a:ln/>
+        </p:spPr>
+        <p:txBody>
+          <a:bodyPr wrap="square" lIns="0" tIns="0" rIns="0" bIns="0" rtlCol="0" anchor="t"/>
+          <a:lstStyle/>
+          <a:p>
+            <a:pPr algn="l" indent="0" marL="0">
+              <a:spcAft>
+                <a:spcPts val="1000"/>
+              </a:spcAft>
+              <a:buNone/>
+            </a:pPr>
+            <a:r>
+              <a:rPr lang="en-US" sz="1400" b="1" dirty="0">
+                <a:solidFill>
+                  <a:srgbClr val="E41159"/>
+                </a:solidFill>
+                <a:latin typeface="Arial" pitchFamily="34" charset="0"/>
+                <a:ea typeface="Arial" pitchFamily="34" charset="-122"/>
+                <a:cs typeface="Arial" pitchFamily="34" charset="-120"/>
+              </a:rPr>
+              <a:t>The Problem</a:t>
+            </a:r>
+            <a:endParaRPr lang="en-US" sz="1400" dirty="0"/>
+          </a:p>
+        </p:txBody>
+      </p:sp>
+      <p:sp>
+        <p:nvSpPr>
+          <p:cNvPr id="5" name="Text 3"/>
+          <p:cNvSpPr/>
+          <p:nvPr/>
+        </p:nvSpPr>
+        <p:spPr>
+          <a:xfrm>
+            <a:off x="381000" y="1298525"/>
+            <a:ext cx="3930700" cy="914102"/>
+          </a:xfrm>
+          <a:prstGeom prst="rect">
+            <a:avLst/>
+          </a:prstGeom>
+          <a:noFill/>
+          <a:ln/>
+        </p:spPr>
+        <p:txBody>
+          <a:bodyPr wrap="square" lIns="114300" tIns="0" rIns="0" bIns="0" rtlCol="0" anchor="t"/>
+          <a:lstStyle/>
+          <a:p>
+            <a:pPr algn="l" marL="114300" indent="-114300">
+              <a:spcAft>
+                <a:spcPts val="800"/>
+              </a:spcAft>
+              <a:buSzPct val="100000"/>
+              <a:buChar char="•"/>
+            </a:pPr>
+            <a:r>
+              <a:rPr lang="en-US" sz="1100" dirty="0">
+                <a:solidFill>
+                  <a:srgbClr val="110A29"/>
+                </a:solidFill>
+                <a:latin typeface="Arial" pitchFamily="34" charset="0"/>
+                <a:ea typeface="Arial" pitchFamily="34" charset="-122"/>
+                <a:cs typeface="Arial" pitchFamily="34" charset="-120"/>
+              </a:rPr>
+              <a:t>MusicXML is extremely verbose (~14K tokens per page)</a:t>
+            </a:r>
+            <a:endParaRPr lang="en-US" sz="1100" dirty="0"/>
+          </a:p>
+          <a:p>
+            <a:pPr algn="l" marL="114300" indent="-114300">
+              <a:spcAft>
+                <a:spcPts val="800"/>
+              </a:spcAft>
+              <a:buSzPct val="100000"/>
+              <a:buChar char="•"/>
+            </a:pPr>
+            <a:r>
+              <a:rPr lang="en-US" sz="1100" dirty="0">
+                <a:solidFill>
+                  <a:srgbClr val="110A29"/>
+                </a:solidFill>
+                <a:latin typeface="Arial" pitchFamily="34" charset="0"/>
+                <a:ea typeface="Arial" pitchFamily="34" charset="-122"/>
+                <a:cs typeface="Arial" pitchFamily="34" charset="-120"/>
+              </a:rPr>
+              <a:t>VLM context window: 4,096 tokens</a:t>
+            </a:r>
+            <a:endParaRPr lang="en-US" sz="1100" dirty="0"/>
+          </a:p>
+          <a:p>
+            <a:pPr algn="l" marL="114300" indent="-114300">
+              <a:spcAft>
+                <a:spcPts val="800"/>
+              </a:spcAft>
+              <a:buSzPct val="100000"/>
+              <a:buChar char="•"/>
+            </a:pPr>
+            <a:r>
+              <a:rPr lang="en-US" sz="1100" dirty="0">
+                <a:solidFill>
+                  <a:srgbClr val="110A29"/>
+                </a:solidFill>
+                <a:latin typeface="Arial" pitchFamily="34" charset="0"/>
+                <a:ea typeface="Arial" pitchFamily="34" charset="-122"/>
+                <a:cs typeface="Arial" pitchFamily="34" charset="-120"/>
+              </a:rPr>
+              <a:t>Only 10% of pages fit — models never reach note elements</a:t>
+            </a:r>
+            <a:endParaRPr lang="en-US" sz="1100" dirty="0"/>
+          </a:p>
+          <a:p>
+            <a:pPr algn="l" marL="114300" indent="-114300">
+              <a:spcAft>
+                <a:spcPts val="800"/>
+              </a:spcAft>
+              <a:buSzPct val="100000"/>
+              <a:buChar char="•"/>
+            </a:pPr>
+            <a:r>
+              <a:rPr lang="en-US" sz="1100" dirty="0">
+                <a:solidFill>
+                  <a:srgbClr val="110A29"/>
+                </a:solidFill>
+                <a:latin typeface="Arial" pitchFamily="34" charset="0"/>
+                <a:ea typeface="Arial" pitchFamily="34" charset="-122"/>
+                <a:cs typeface="Arial" pitchFamily="34" charset="-120"/>
+              </a:rPr>
+              <a:t>All models generate headers/metadata, never actual notes</a:t>
+            </a:r>
+            <a:endParaRPr lang="en-US" sz="1100" dirty="0"/>
+          </a:p>
+        </p:txBody>
+      </p:sp>
+      <p:sp>
+        <p:nvSpPr>
+          <p:cNvPr id="6" name="Text 4"/>
+          <p:cNvSpPr/>
+          <p:nvPr/>
+        </p:nvSpPr>
+        <p:spPr>
+          <a:xfrm>
+            <a:off x="4565600" y="962025"/>
+            <a:ext cx="12650" cy="4029075"/>
+          </a:xfrm>
+          <a:prstGeom prst="rect">
+            <a:avLst/>
+          </a:prstGeom>
+          <a:solidFill>
+            <a:srgbClr val="D9D5D2"/>
+          </a:solidFill>
+          <a:ln/>
+        </p:spPr>
+        <p:txBody>
+          <a:bodyPr wrap="square" rtlCol="0" anchor="ctr"/>
+          <a:lstStyle/>
+          <a:p>
+            <a:pPr indent="0" marL="0">
+              <a:buNone/>
+            </a:pPr>
+            <a:endParaRPr lang="en-US" dirty="0"/>
+          </a:p>
+        </p:txBody>
+      </p:sp>
+      <p:sp>
+        <p:nvSpPr>
+          <p:cNvPr id="7" name="Text 5"/>
+          <p:cNvSpPr/>
+          <p:nvPr/>
+        </p:nvSpPr>
+        <p:spPr>
+          <a:xfrm>
+            <a:off x="4832152" y="962025"/>
+            <a:ext cx="4009465" cy="209550"/>
+          </a:xfrm>
+          <a:prstGeom prst="rect">
+            <a:avLst/>
+          </a:prstGeom>
+          <a:noFill/>
+          <a:ln/>
+        </p:spPr>
+        <p:txBody>
+          <a:bodyPr wrap="square" lIns="0" tIns="0" rIns="0" bIns="0" rtlCol="0" anchor="t"/>
+          <a:lstStyle/>
+          <a:p>
+            <a:pPr algn="l" indent="0" marL="0">
+              <a:spcAft>
+                <a:spcPts val="1000"/>
+              </a:spcAft>
+              <a:buNone/>
+            </a:pPr>
+            <a:r>
+              <a:rPr lang="en-US" sz="1400" b="1" dirty="0">
+                <a:solidFill>
+                  <a:srgbClr val="E41159"/>
+                </a:solidFill>
+                <a:latin typeface="Arial" pitchFamily="34" charset="0"/>
+                <a:ea typeface="Arial" pitchFamily="34" charset="-122"/>
+                <a:cs typeface="Arial" pitchFamily="34" charset="-120"/>
+              </a:rPr>
+              <a:t>The Impact</a:t>
+            </a:r>
+            <a:endParaRPr lang="en-US" sz="1400" dirty="0"/>
+          </a:p>
+        </p:txBody>
+      </p:sp>
+      <p:sp>
+        <p:nvSpPr>
+          <p:cNvPr id="8" name="Text 6"/>
+          <p:cNvSpPr/>
+          <p:nvPr/>
+        </p:nvSpPr>
+        <p:spPr>
+          <a:xfrm>
+            <a:off x="4832152" y="1298525"/>
+            <a:ext cx="3930848" cy="914102"/>
+          </a:xfrm>
+          <a:prstGeom prst="rect">
+            <a:avLst/>
+          </a:prstGeom>
+          <a:noFill/>
+          <a:ln/>
+        </p:spPr>
+        <p:txBody>
+          <a:bodyPr wrap="square" lIns="114300" tIns="0" rIns="0" bIns="0" rtlCol="0" anchor="t"/>
+          <a:lstStyle/>
+          <a:p>
+            <a:pPr algn="l" marL="114300" indent="-114300">
+              <a:spcAft>
+                <a:spcPts val="800"/>
+              </a:spcAft>
+              <a:buSzPct val="100000"/>
+              <a:buChar char="•"/>
+            </a:pPr>
+            <a:r>
+              <a:rPr lang="en-US" sz="1100" dirty="0">
+                <a:solidFill>
+                  <a:srgbClr val="110A29"/>
+                </a:solidFill>
+                <a:latin typeface="Arial" pitchFamily="34" charset="0"/>
+                <a:ea typeface="Arial" pitchFamily="34" charset="-122"/>
+                <a:cs typeface="Arial" pitchFamily="34" charset="-120"/>
+              </a:rPr>
+              <a:t>6 models tested with XML targets</a:t>
+            </a:r>
+            <a:endParaRPr lang="en-US" sz="1100" dirty="0"/>
+          </a:p>
+          <a:p>
+            <a:pPr algn="l" marL="114300" indent="-114300">
+              <a:spcAft>
+                <a:spcPts val="800"/>
+              </a:spcAft>
+              <a:buSzPct val="100000"/>
+              <a:buChar char="•"/>
+            </a:pPr>
+            <a:r>
+              <a:rPr lang="en-US" sz="1100" b="1" dirty="0">
+                <a:solidFill>
+                  <a:srgbClr val="110A29"/>
+                </a:solidFill>
+                <a:latin typeface="Arial" pitchFamily="34" charset="0"/>
+                <a:ea typeface="Arial" pitchFamily="34" charset="-122"/>
+                <a:cs typeface="Arial" pitchFamily="34" charset="-120"/>
+              </a:rPr>
+              <a:t>0% pitch accuracy</a:t>
+            </a:r>
+            <a:pPr algn="l" indent="0" marL="0">
+              <a:spcAft>
+                <a:spcPts val="800"/>
+              </a:spcAft>
+              <a:buNone/>
+            </a:pPr>
+            <a:r>
+              <a:rPr lang="en-US" sz="1100" dirty="0">
+                <a:solidFill>
+                  <a:srgbClr val="110A29"/>
+                </a:solidFill>
+                <a:latin typeface="Arial" pitchFamily="34" charset="0"/>
+                <a:ea typeface="Arial" pitchFamily="34" charset="-122"/>
+                <a:cs typeface="Arial" pitchFamily="34" charset="-120"/>
+              </a:rPr>
+              <a:t> across all models</a:t>
+            </a:r>
+            <a:endParaRPr lang="en-US" sz="1100" dirty="0"/>
+          </a:p>
+          <a:p>
+            <a:pPr algn="l" marL="114300" indent="-114300">
+              <a:spcAft>
+                <a:spcPts val="800"/>
+              </a:spcAft>
+              <a:buSzPct val="100000"/>
+              <a:buChar char="•"/>
+            </a:pPr>
+            <a:r>
+              <a:rPr lang="en-US" sz="1100" dirty="0">
+                <a:solidFill>
+                  <a:srgbClr val="110A29"/>
+                </a:solidFill>
+                <a:latin typeface="Arial" pitchFamily="34" charset="0"/>
+                <a:ea typeface="Arial" pitchFamily="34" charset="-122"/>
+                <a:cs typeface="Arial" pitchFamily="34" charset="-120"/>
+              </a:rPr>
+              <a:t>Models learn structure but not musical content</a:t>
+            </a:r>
+            <a:endParaRPr lang="en-US" sz="1100" dirty="0"/>
+          </a:p>
+          <a:p>
+            <a:pPr algn="l" marL="114300" indent="-114300">
+              <a:spcAft>
+                <a:spcPts val="800"/>
+              </a:spcAft>
+              <a:buSzPct val="100000"/>
+              <a:buChar char="•"/>
+            </a:pPr>
+            <a:r>
+              <a:rPr lang="en-US" sz="1100" dirty="0">
+                <a:solidFill>
+                  <a:srgbClr val="110A29"/>
+                </a:solidFill>
+                <a:latin typeface="Arial" pitchFamily="34" charset="0"/>
+                <a:ea typeface="Arial" pitchFamily="34" charset="-122"/>
+                <a:cs typeface="Arial" pitchFamily="34" charset="-120"/>
+              </a:rPr>
+              <a:t>Need 12x compression to fit notes in context</a:t>
+            </a:r>
+            <a:endParaRPr lang="en-US" sz="1100" dirty="0"/>
+          </a:p>
+        </p:txBody>
+      </p:sp>
+      <p:pic>
+        <p:nvPicPr>
+          <p:cNvPr id="9" name="Image 0" descr="/home/zsi/projects/worktrees/CVlization/vintage-music-sheet/examples/perception/optical_music_recognition/slides-omr-mxc/kungfu-logo.png">    </p:cNvPr>
+          <p:cNvPicPr>
+            <a:picLocks noChangeAspect="1"/>
+          </p:cNvPicPr>
+          <p:nvPr/>
+        </p:nvPicPr>
+        <p:blipFill>
+          <a:blip r:embed="rId1"/>
+          <a:stretch>
+            <a:fillRect/>
+          </a:stretch>
+        </p:blipFill>
+        <p:spPr>
+          <a:xfrm>
+            <a:off x="8255198" y="4562624"/>
+            <a:ext cx="634901" cy="453926"/>
+          </a:xfrm>
+          <a:prstGeom prst="rect">
+            <a:avLst/>
+          </a:prstGeom>
+        </p:spPr>
+      </p:pic>
+    </p:spTree>
+  </p:cSld>
+  <p:clrMapOvr>
+    <a:masterClrMapping/>
+  </p:clrMapOvr>
+</p:sld>
+</file>
+
+<file path=ppt/slides/slide12.xml><?xml version="1.0" encoding="utf-8"?>
+<p:sld xmlns:a="http://schemas.openxmlformats.org/drawingml/2006/main" xmlns:r="http://schemas.openxmlformats.org/officeDocument/2006/relationships" xmlns:p="http://schemas.openxmlformats.org/presentationml/2006/main">
+  <p:cSld name="Slide 12">
+    <p:bg>
+      <p:bgPr>
+        <a:solidFill>
+          <a:srgbClr val="FFFFFF"/>
+        </a:solidFill>
+      </p:bgPr>
+    </p:bg>
+    <p:spTree>
+      <p:nvGrpSpPr>
+        <p:cNvPr id="1" name=""/>
+        <p:cNvGrpSpPr/>
+        <p:nvPr/>
+      </p:nvGrpSpPr>
+      <p:grpSpPr>
+        <a:xfrm>
+          <a:off x="0" y="0"/>
+          <a:ext cx="0" cy="0"/>
+          <a:chOff x="0" y="0"/>
+          <a:chExt cx="0" cy="0"/>
+        </a:xfrm>
+      </p:grpSpPr>
+      <p:sp>
+        <p:nvSpPr>
+          <p:cNvPr id="2" name="Text 0"/>
+          <p:cNvSpPr/>
+          <p:nvPr/>
+        </p:nvSpPr>
+        <p:spPr>
+          <a:xfrm>
+            <a:off x="0" y="0"/>
+            <a:ext cx="9144000" cy="809625"/>
+          </a:xfrm>
+          <a:prstGeom prst="rect">
+            <a:avLst/>
+          </a:prstGeom>
+          <a:solidFill>
+            <a:srgbClr val="E41159"/>
+          </a:solidFill>
+          <a:ln/>
+        </p:spPr>
+        <p:txBody>
+          <a:bodyPr wrap="square" rtlCol="0" anchor="ctr"/>
+          <a:lstStyle/>
+          <a:p>
+            <a:pPr indent="0" marL="0">
+              <a:buNone/>
+            </a:pPr>
+            <a:endParaRPr lang="en-US" dirty="0"/>
+          </a:p>
+        </p:txBody>
+      </p:sp>
+      <p:sp>
+        <p:nvSpPr>
+          <p:cNvPr id="3" name="Text 1"/>
+          <p:cNvSpPr/>
+          <p:nvPr/>
+        </p:nvSpPr>
+        <p:spPr>
+          <a:xfrm>
+            <a:off x="381000" y="228600"/>
+            <a:ext cx="8549640" cy="352425"/>
+          </a:xfrm>
+          <a:prstGeom prst="rect">
+            <a:avLst/>
+          </a:prstGeom>
+          <a:noFill/>
+          <a:ln/>
+        </p:spPr>
+        <p:txBody>
+          <a:bodyPr wrap="square" lIns="0" tIns="0" rIns="0" bIns="0" rtlCol="0" anchor="t"/>
+          <a:lstStyle/>
+          <a:p>
+            <a:pPr algn="l" indent="0" marL="0">
+              <a:buNone/>
+            </a:pPr>
+            <a:r>
+              <a:rPr lang="en-US" sz="2400" b="1" dirty="0">
+                <a:solidFill>
+                  <a:srgbClr val="FFFFFF"/>
+                </a:solidFill>
+                <a:latin typeface="Arial" pitchFamily="34" charset="0"/>
+                <a:ea typeface="Arial" pitchFamily="34" charset="-122"/>
+                <a:cs typeface="Arial" pitchFamily="34" charset="-120"/>
+              </a:rPr>
+              <a:t>MXC: MusicXML Compact</a:t>
+            </a:r>
+            <a:endParaRPr lang="en-US" sz="2400" dirty="0"/>
+          </a:p>
+        </p:txBody>
+      </p:sp>
+      <p:sp>
+        <p:nvSpPr>
+          <p:cNvPr id="4" name="Text 2"/>
+          <p:cNvSpPr/>
+          <p:nvPr/>
+        </p:nvSpPr>
+        <p:spPr>
+          <a:xfrm>
+            <a:off x="381000" y="962025"/>
+            <a:ext cx="4009314" cy="209550"/>
+          </a:xfrm>
+          <a:prstGeom prst="rect">
+            <a:avLst/>
+          </a:prstGeom>
+          <a:noFill/>
+          <a:ln/>
+        </p:spPr>
+        <p:txBody>
+          <a:bodyPr wrap="square" lIns="0" tIns="0" rIns="0" bIns="0" rtlCol="0" anchor="t"/>
+          <a:lstStyle/>
+          <a:p>
+            <a:pPr algn="l" indent="0" marL="0">
+              <a:spcAft>
+                <a:spcPts val="1000"/>
+              </a:spcAft>
+              <a:buNone/>
+            </a:pPr>
+            <a:r>
+              <a:rPr lang="en-US" sz="1400" b="1" dirty="0">
+                <a:solidFill>
+                  <a:srgbClr val="E41159"/>
+                </a:solidFill>
+                <a:latin typeface="Arial" pitchFamily="34" charset="0"/>
+                <a:ea typeface="Arial" pitchFamily="34" charset="-122"/>
+                <a:cs typeface="Arial" pitchFamily="34" charset="-120"/>
+              </a:rPr>
+              <a:t>Design</a:t>
+            </a:r>
+            <a:endParaRPr lang="en-US" sz="1400" dirty="0"/>
+          </a:p>
+        </p:txBody>
+      </p:sp>
+      <p:sp>
+        <p:nvSpPr>
+          <p:cNvPr id="5" name="Text 3"/>
+          <p:cNvSpPr/>
+          <p:nvPr/>
+        </p:nvSpPr>
+        <p:spPr>
+          <a:xfrm>
+            <a:off x="381000" y="1298525"/>
+            <a:ext cx="3930700" cy="838051"/>
+          </a:xfrm>
+          <a:prstGeom prst="rect">
+            <a:avLst/>
+          </a:prstGeom>
+          <a:noFill/>
+          <a:ln/>
+        </p:spPr>
+        <p:txBody>
+          <a:bodyPr wrap="square" lIns="114300" tIns="0" rIns="0" bIns="0" rtlCol="0" anchor="t"/>
+          <a:lstStyle/>
+          <a:p>
+            <a:pPr algn="l" marL="114300" indent="-114300">
+              <a:spcAft>
+                <a:spcPts val="700"/>
+              </a:spcAft>
+              <a:buSzPct val="100000"/>
+              <a:buChar char="•"/>
+            </a:pPr>
+            <a:r>
+              <a:rPr lang="en-US" sz="1000" dirty="0">
+                <a:solidFill>
+                  <a:srgbClr val="110A29"/>
+                </a:solidFill>
+                <a:latin typeface="Arial" pitchFamily="34" charset="0"/>
+                <a:ea typeface="Arial" pitchFamily="34" charset="-122"/>
+                <a:cs typeface="Arial" pitchFamily="34" charset="-120"/>
+              </a:rPr>
+              <a:t>Line-based encoding: one note = one line</a:t>
+            </a:r>
+            <a:endParaRPr lang="en-US" sz="1000" dirty="0"/>
+          </a:p>
+          <a:p>
+            <a:pPr algn="l" marL="114300" indent="-114300">
+              <a:spcAft>
+                <a:spcPts val="700"/>
+              </a:spcAft>
+              <a:buSzPct val="100000"/>
+              <a:buChar char="•"/>
+            </a:pPr>
+            <a:r>
+              <a:rPr lang="en-US" sz="1000" b="1" dirty="0">
+                <a:solidFill>
+                  <a:srgbClr val="110A29"/>
+                </a:solidFill>
+                <a:latin typeface="Arial" pitchFamily="34" charset="0"/>
+                <a:ea typeface="Arial" pitchFamily="34" charset="-122"/>
+                <a:cs typeface="Arial" pitchFamily="34" charset="-120"/>
+              </a:rPr>
+              <a:t>N C4 q 10080 su L1:s:Lord,</a:t>
+            </a:r>
+            <a:pPr algn="l" indent="0" marL="0">
+              <a:spcAft>
+                <a:spcPts val="700"/>
+              </a:spcAft>
+              <a:buNone/>
+            </a:pPr>
+            <a:r>
+              <a:rPr lang="en-US" sz="1000" dirty="0">
+                <a:solidFill>
+                  <a:srgbClr val="110A29"/>
+                </a:solidFill>
+                <a:latin typeface="Arial" pitchFamily="34" charset="0"/>
+                <a:ea typeface="Arial" pitchFamily="34" charset="-122"/>
+                <a:cs typeface="Arial" pitchFamily="34" charset="-120"/>
+              </a:rPr>
+              <a:t> = quarter C4, stem up, lyric</a:t>
+            </a:r>
+            <a:endParaRPr lang="en-US" sz="1000" dirty="0"/>
+          </a:p>
+          <a:p>
+            <a:pPr algn="l" marL="114300" indent="-114300">
+              <a:spcAft>
+                <a:spcPts val="700"/>
+              </a:spcAft>
+              <a:buSzPct val="100000"/>
+              <a:buChar char="•"/>
+            </a:pPr>
+            <a:r>
+              <a:rPr lang="en-US" sz="1000" b="1" dirty="0">
+                <a:solidFill>
+                  <a:srgbClr val="110A29"/>
+                </a:solidFill>
+                <a:latin typeface="Arial" pitchFamily="34" charset="0"/>
+                <a:ea typeface="Arial" pitchFamily="34" charset="-122"/>
+                <a:cs typeface="Arial" pitchFamily="34" charset="-120"/>
+              </a:rPr>
+              <a:t>12x compression:</a:t>
+            </a:r>
+            <a:pPr algn="l" indent="0" marL="0">
+              <a:spcAft>
+                <a:spcPts val="700"/>
+              </a:spcAft>
+              <a:buNone/>
+            </a:pPr>
+            <a:r>
+              <a:rPr lang="en-US" sz="1000" dirty="0">
+                <a:solidFill>
+                  <a:srgbClr val="110A29"/>
+                </a:solidFill>
+                <a:latin typeface="Arial" pitchFamily="34" charset="0"/>
+                <a:ea typeface="Arial" pitchFamily="34" charset="-122"/>
+                <a:cs typeface="Arial" pitchFamily="34" charset="-120"/>
+              </a:rPr>
+              <a:t> 14K tokens → 1.2K tokens</a:t>
+            </a:r>
+            <a:endParaRPr lang="en-US" sz="1000" dirty="0"/>
+          </a:p>
+          <a:p>
+            <a:pPr algn="l" marL="114300" indent="-114300">
+              <a:spcAft>
+                <a:spcPts val="700"/>
+              </a:spcAft>
+              <a:buSzPct val="100000"/>
+              <a:buChar char="•"/>
+            </a:pPr>
+            <a:r>
+              <a:rPr lang="en-US" sz="1000" dirty="0">
+                <a:solidFill>
+                  <a:srgbClr val="110A29"/>
+                </a:solidFill>
+                <a:latin typeface="Arial" pitchFamily="34" charset="0"/>
+                <a:ea typeface="Arial" pitchFamily="34" charset="-122"/>
+                <a:cs typeface="Arial" pitchFamily="34" charset="-120"/>
+              </a:rPr>
+              <a:t>99.2% lossless round-trip on 500 samples</a:t>
+            </a:r>
+            <a:endParaRPr lang="en-US" sz="1000" dirty="0"/>
+          </a:p>
+        </p:txBody>
+      </p:sp>
+      <p:sp>
+        <p:nvSpPr>
+          <p:cNvPr id="6" name="Text 4"/>
+          <p:cNvSpPr/>
+          <p:nvPr/>
+        </p:nvSpPr>
+        <p:spPr>
+          <a:xfrm>
+            <a:off x="4565600" y="962025"/>
+            <a:ext cx="12650" cy="4029075"/>
+          </a:xfrm>
+          <a:prstGeom prst="rect">
+            <a:avLst/>
+          </a:prstGeom>
+          <a:solidFill>
+            <a:srgbClr val="D9D5D2"/>
+          </a:solidFill>
+          <a:ln/>
+        </p:spPr>
+        <p:txBody>
+          <a:bodyPr wrap="square" rtlCol="0" anchor="ctr"/>
+          <a:lstStyle/>
+          <a:p>
+            <a:pPr indent="0" marL="0">
+              <a:buNone/>
+            </a:pPr>
+            <a:endParaRPr lang="en-US" dirty="0"/>
+          </a:p>
+        </p:txBody>
+      </p:sp>
+      <p:sp>
+        <p:nvSpPr>
+          <p:cNvPr id="7" name="Text 5"/>
+          <p:cNvSpPr/>
+          <p:nvPr/>
+        </p:nvSpPr>
+        <p:spPr>
+          <a:xfrm>
+            <a:off x="4832152" y="962025"/>
+            <a:ext cx="4009465" cy="209550"/>
+          </a:xfrm>
+          <a:prstGeom prst="rect">
+            <a:avLst/>
+          </a:prstGeom>
+          <a:noFill/>
+          <a:ln/>
+        </p:spPr>
+        <p:txBody>
+          <a:bodyPr wrap="square" lIns="0" tIns="0" rIns="0" bIns="0" rtlCol="0" anchor="t"/>
+          <a:lstStyle/>
+          <a:p>
+            <a:pPr algn="l" indent="0" marL="0">
+              <a:spcAft>
+                <a:spcPts val="1000"/>
+              </a:spcAft>
+              <a:buNone/>
+            </a:pPr>
+            <a:r>
+              <a:rPr lang="en-US" sz="1400" b="1" dirty="0">
+                <a:solidFill>
+                  <a:srgbClr val="E41159"/>
+                </a:solidFill>
+                <a:latin typeface="Arial" pitchFamily="34" charset="0"/>
+                <a:ea typeface="Arial" pitchFamily="34" charset="-122"/>
+                <a:cs typeface="Arial" pitchFamily="34" charset="-120"/>
+              </a:rPr>
+              <a:t>What It Preserves</a:t>
+            </a:r>
+            <a:endParaRPr lang="en-US" sz="1400" dirty="0"/>
+          </a:p>
+        </p:txBody>
+      </p:sp>
+      <p:sp>
+        <p:nvSpPr>
+          <p:cNvPr id="8" name="Text 6"/>
+          <p:cNvSpPr/>
+          <p:nvPr/>
+        </p:nvSpPr>
+        <p:spPr>
+          <a:xfrm>
+            <a:off x="4832152" y="1298525"/>
+            <a:ext cx="3930848" cy="1069777"/>
+          </a:xfrm>
+          <a:prstGeom prst="rect">
+            <a:avLst/>
+          </a:prstGeom>
+          <a:noFill/>
+          <a:ln/>
+        </p:spPr>
+        <p:txBody>
+          <a:bodyPr wrap="square" lIns="114300" tIns="0" rIns="0" bIns="0" rtlCol="0" anchor="t"/>
+          <a:lstStyle/>
+          <a:p>
+            <a:pPr algn="l" marL="114300" indent="-114300">
+              <a:spcAft>
+                <a:spcPts val="700"/>
+              </a:spcAft>
+              <a:buSzPct val="100000"/>
+              <a:buChar char="•"/>
+            </a:pPr>
+            <a:r>
+              <a:rPr lang="en-US" sz="1000" dirty="0">
+                <a:solidFill>
+                  <a:srgbClr val="110A29"/>
+                </a:solidFill>
+                <a:latin typeface="Arial" pitchFamily="34" charset="0"/>
+                <a:ea typeface="Arial" pitchFamily="34" charset="-122"/>
+                <a:cs typeface="Arial" pitchFamily="34" charset="-120"/>
+              </a:rPr>
+              <a:t>Pitches, durations, stems, beams</a:t>
+            </a:r>
+            <a:endParaRPr lang="en-US" sz="1000" dirty="0"/>
+          </a:p>
+          <a:p>
+            <a:pPr algn="l" marL="114300" indent="-114300">
+              <a:spcAft>
+                <a:spcPts val="700"/>
+              </a:spcAft>
+              <a:buSzPct val="100000"/>
+              <a:buChar char="•"/>
+            </a:pPr>
+            <a:r>
+              <a:rPr lang="en-US" sz="1000" dirty="0">
+                <a:solidFill>
+                  <a:srgbClr val="110A29"/>
+                </a:solidFill>
+                <a:latin typeface="Arial" pitchFamily="34" charset="0"/>
+                <a:ea typeface="Arial" pitchFamily="34" charset="-122"/>
+                <a:cs typeface="Arial" pitchFamily="34" charset="-120"/>
+              </a:rPr>
+              <a:t>Lyrics (bilingual, syllabic encoding)</a:t>
+            </a:r>
+            <a:endParaRPr lang="en-US" sz="1000" dirty="0"/>
+          </a:p>
+          <a:p>
+            <a:pPr algn="l" marL="114300" indent="-114300">
+              <a:spcAft>
+                <a:spcPts val="700"/>
+              </a:spcAft>
+              <a:buSzPct val="100000"/>
+              <a:buChar char="•"/>
+            </a:pPr>
+            <a:r>
+              <a:rPr lang="en-US" sz="1000" dirty="0">
+                <a:solidFill>
+                  <a:srgbClr val="110A29"/>
+                </a:solidFill>
+                <a:latin typeface="Arial" pitchFamily="34" charset="0"/>
+                <a:ea typeface="Arial" pitchFamily="34" charset="-122"/>
+                <a:cs typeface="Arial" pitchFamily="34" charset="-120"/>
+              </a:rPr>
+              <a:t>Key/time signatures, clefs</a:t>
+            </a:r>
+            <a:endParaRPr lang="en-US" sz="1000" dirty="0"/>
+          </a:p>
+          <a:p>
+            <a:pPr algn="l" marL="114300" indent="-114300">
+              <a:spcAft>
+                <a:spcPts val="700"/>
+              </a:spcAft>
+              <a:buSzPct val="100000"/>
+              <a:buChar char="•"/>
+            </a:pPr>
+            <a:r>
+              <a:rPr lang="en-US" sz="1000" dirty="0">
+                <a:solidFill>
+                  <a:srgbClr val="110A29"/>
+                </a:solidFill>
+                <a:latin typeface="Arial" pitchFamily="34" charset="0"/>
+                <a:ea typeface="Arial" pitchFamily="34" charset="-122"/>
+                <a:cs typeface="Arial" pitchFamily="34" charset="-120"/>
+              </a:rPr>
+              <a:t>Dynamics, directions, barlines</a:t>
+            </a:r>
+            <a:endParaRPr lang="en-US" sz="1000" dirty="0"/>
+          </a:p>
+          <a:p>
+            <a:pPr algn="l" marL="114300" indent="-114300">
+              <a:spcAft>
+                <a:spcPts val="700"/>
+              </a:spcAft>
+              <a:buSzPct val="100000"/>
+              <a:buChar char="•"/>
+            </a:pPr>
+            <a:r>
+              <a:rPr lang="en-US" sz="1000" dirty="0">
+                <a:solidFill>
+                  <a:srgbClr val="110A29"/>
+                </a:solidFill>
+                <a:latin typeface="Arial" pitchFamily="34" charset="0"/>
+                <a:ea typeface="Arial" pitchFamily="34" charset="-122"/>
+                <a:cs typeface="Arial" pitchFamily="34" charset="-120"/>
+              </a:rPr>
+              <a:t>Composer, lyricist, title</a:t>
+            </a:r>
+            <a:endParaRPr lang="en-US" sz="1000" dirty="0"/>
+          </a:p>
+        </p:txBody>
+      </p:sp>
+      <p:pic>
+        <p:nvPicPr>
+          <p:cNvPr id="9" name="Image 0" descr="/home/zsi/projects/worktrees/CVlization/vintage-music-sheet/examples/perception/optical_music_recognition/slides-omr-mxc/kungfu-logo.png">    </p:cNvPr>
+          <p:cNvPicPr>
+            <a:picLocks noChangeAspect="1"/>
+          </p:cNvPicPr>
+          <p:nvPr/>
+        </p:nvPicPr>
+        <p:blipFill>
+          <a:blip r:embed="rId1"/>
+          <a:stretch>
+            <a:fillRect/>
+          </a:stretch>
+        </p:blipFill>
+        <p:spPr>
+          <a:xfrm>
+            <a:off x="8255198" y="4562624"/>
+            <a:ext cx="634901" cy="453926"/>
+          </a:xfrm>
+          <a:prstGeom prst="rect">
+            <a:avLst/>
+          </a:prstGeom>
+        </p:spPr>
+      </p:pic>
+    </p:spTree>
+  </p:cSld>
+  <p:clrMapOvr>
+    <a:masterClrMapping/>
+  </p:clrMapOvr>
+</p:sld>
+</file>
+
+<file path=ppt/slides/slide13.xml><?xml version="1.0" encoding="utf-8"?>
+<p:sld xmlns:a="http://schemas.openxmlformats.org/drawingml/2006/main" xmlns:r="http://schemas.openxmlformats.org/officeDocument/2006/relationships" xmlns:p="http://schemas.openxmlformats.org/presentationml/2006/main">
+  <p:cSld name="Slide 13">
+    <p:bg>
+      <p:bgPr>
+        <a:solidFill>
+          <a:srgbClr val="FFFFFF"/>
+        </a:solidFill>
+      </p:bgPr>
+    </p:bg>
+    <p:spTree>
+      <p:nvGrpSpPr>
+        <p:cNvPr id="1" name=""/>
+        <p:cNvGrpSpPr/>
+        <p:nvPr/>
+      </p:nvGrpSpPr>
+      <p:grpSpPr>
+        <a:xfrm>
+          <a:off x="0" y="0"/>
+          <a:ext cx="0" cy="0"/>
+          <a:chOff x="0" y="0"/>
+          <a:chExt cx="0" cy="0"/>
+        </a:xfrm>
+      </p:grpSpPr>
+      <p:sp>
+        <p:nvSpPr>
+          <p:cNvPr id="2" name="Text 0"/>
+          <p:cNvSpPr/>
+          <p:nvPr/>
+        </p:nvSpPr>
+        <p:spPr>
+          <a:xfrm>
+            <a:off x="0" y="0"/>
+            <a:ext cx="9144000" cy="809625"/>
+          </a:xfrm>
+          <a:prstGeom prst="rect">
+            <a:avLst/>
+          </a:prstGeom>
+          <a:solidFill>
+            <a:srgbClr val="E41159"/>
+          </a:solidFill>
+          <a:ln/>
+        </p:spPr>
+        <p:txBody>
+          <a:bodyPr wrap="square" rtlCol="0" anchor="ctr"/>
+          <a:lstStyle/>
+          <a:p>
+            <a:pPr indent="0" marL="0">
+              <a:buNone/>
+            </a:pPr>
+            <a:endParaRPr lang="en-US" dirty="0"/>
+          </a:p>
+        </p:txBody>
+      </p:sp>
+      <p:sp>
+        <p:nvSpPr>
+          <p:cNvPr id="3" name="Text 1"/>
+          <p:cNvSpPr/>
+          <p:nvPr/>
+        </p:nvSpPr>
+        <p:spPr>
+          <a:xfrm>
+            <a:off x="381000" y="228600"/>
+            <a:ext cx="8549640" cy="352425"/>
+          </a:xfrm>
+          <a:prstGeom prst="rect">
+            <a:avLst/>
+          </a:prstGeom>
+          <a:noFill/>
+          <a:ln/>
+        </p:spPr>
+        <p:txBody>
+          <a:bodyPr wrap="square" lIns="0" tIns="0" rIns="0" bIns="0" rtlCol="0" anchor="t"/>
+          <a:lstStyle/>
+          <a:p>
+            <a:pPr algn="l" indent="0" marL="0">
+              <a:buNone/>
+            </a:pPr>
+            <a:r>
+              <a:rPr lang="en-US" sz="2400" b="1" dirty="0">
+                <a:solidFill>
+                  <a:srgbClr val="FFFFFF"/>
+                </a:solidFill>
+                <a:latin typeface="Arial" pitchFamily="34" charset="0"/>
+                <a:ea typeface="Arial" pitchFamily="34" charset="-122"/>
+                <a:cs typeface="Arial" pitchFamily="34" charset="-120"/>
+              </a:rPr>
+              <a:t>Model Comparison — MXC Targets</a:t>
+            </a:r>
+            <a:endParaRPr lang="en-US" sz="2400" dirty="0"/>
+          </a:p>
+        </p:txBody>
+      </p:sp>
+      <p:pic>
+        <p:nvPicPr>
+          <p:cNvPr id="4" name="Image 0" descr="/home/zsi/projects/worktrees/CVlization/vintage-music-sheet/examples/perception/optical_music_recognition/slides-omr-mxc/kungfu-logo.png">    </p:cNvPr>
+          <p:cNvPicPr>
+            <a:picLocks noChangeAspect="1"/>
+          </p:cNvPicPr>
+          <p:nvPr/>
+        </p:nvPicPr>
+        <p:blipFill>
+          <a:blip r:embed="rId1"/>
+          <a:stretch>
+            <a:fillRect/>
+          </a:stretch>
+        </p:blipFill>
+        <p:spPr>
+          <a:xfrm>
+            <a:off x="8255198" y="4562624"/>
+            <a:ext cx="634901" cy="453926"/>
+          </a:xfrm>
+          <a:prstGeom prst="rect">
+            <a:avLst/>
+          </a:prstGeom>
+        </p:spPr>
+      </p:pic>
       <p:graphicFrame>
         <p:nvGraphicFramePr>
-          <p:cNvPr id="11" name="Table 0"/>
+          <p:cNvPr id="14" name="Table 0"/>
           <p:cNvGraphicFramePr>
             <a:graphicFrameLocks noGrp="1"/>
           </p:cNvGraphicFramePr>
@@ -4612,9 +6671,9 @@
 </p:sld>
 </file>
 
-<file path=ppt/slides/slide11.xml><?xml version="1.0" encoding="utf-8"?>
+<file path=ppt/slides/slide14.xml><?xml version="1.0" encoding="utf-8"?>
 <p:sld xmlns:a="http://schemas.openxmlformats.org/drawingml/2006/main" xmlns:r="http://schemas.openxmlformats.org/officeDocument/2006/relationships" xmlns:p="http://schemas.openxmlformats.org/presentationml/2006/main">
-  <p:cSld name="Slide 11">
+  <p:cSld name="Slide 14">
     <p:bg>
       <p:bgPr>
         <a:solidFill>
@@ -5042,9 +7101,9 @@
 </p:sld>
 </file>
 
-<file path=ppt/slides/slide12.xml><?xml version="1.0" encoding="utf-8"?>
+<file path=ppt/slides/slide15.xml><?xml version="1.0" encoding="utf-8"?>
 <p:sld xmlns:a="http://schemas.openxmlformats.org/drawingml/2006/main" xmlns:r="http://schemas.openxmlformats.org/officeDocument/2006/relationships" xmlns:p="http://schemas.openxmlformats.org/presentationml/2006/main">
-  <p:cSld name="Slide 12">
+  <p:cSld name="Slide 15">
     <p:bg>
       <p:bgPr>
         <a:solidFill>
@@ -5458,9 +7517,9 @@
 </p:sld>
 </file>
 
-<file path=ppt/slides/slide13.xml><?xml version="1.0" encoding="utf-8"?>
+<file path=ppt/slides/slide16.xml><?xml version="1.0" encoding="utf-8"?>
 <p:sld xmlns:a="http://schemas.openxmlformats.org/drawingml/2006/main" xmlns:r="http://schemas.openxmlformats.org/officeDocument/2006/relationships" xmlns:p="http://schemas.openxmlformats.org/presentationml/2006/main">
-  <p:cSld name="Slide 13">
+  <p:cSld name="Slide 16">
     <p:bg>
       <p:bgPr>
         <a:solidFill>
@@ -5661,7 +7720,7 @@
       </p:pic>
       <p:graphicFrame>
         <p:nvGraphicFramePr>
-          <p:cNvPr id="14" name="Table 0"/>
+          <p:cNvPr id="17" name="Table 0"/>
           <p:cNvGraphicFramePr>
             <a:graphicFrameLocks noGrp="1"/>
           </p:cNvGraphicFramePr>
@@ -6647,9 +8706,9 @@
 </p:sld>
 </file>
 
-<file path=ppt/slides/slide14.xml><?xml version="1.0" encoding="utf-8"?>
+<file path=ppt/slides/slide17.xml><?xml version="1.0" encoding="utf-8"?>
 <p:sld xmlns:a="http://schemas.openxmlformats.org/drawingml/2006/main" xmlns:r="http://schemas.openxmlformats.org/officeDocument/2006/relationships" xmlns:p="http://schemas.openxmlformats.org/presentationml/2006/main">
-  <p:cSld name="Slide 14">
+  <p:cSld name="Slide 17">
     <p:bg>
       <p:bgPr>
         <a:solidFill>
@@ -7252,9 +9311,9 @@
 </p:sld>
 </file>
 
-<file path=ppt/slides/slide15.xml><?xml version="1.0" encoding="utf-8"?>
+<file path=ppt/slides/slide18.xml><?xml version="1.0" encoding="utf-8"?>
 <p:sld xmlns:a="http://schemas.openxmlformats.org/drawingml/2006/main" xmlns:r="http://schemas.openxmlformats.org/officeDocument/2006/relationships" xmlns:p="http://schemas.openxmlformats.org/presentationml/2006/main">
-  <p:cSld name="Slide 15">
+  <p:cSld name="Slide 18">
     <p:bg>
       <p:bgPr>
         <a:solidFill>
@@ -7643,9 +9702,9 @@
 </p:sld>
 </file>
 
-<file path=ppt/slides/slide16.xml><?xml version="1.0" encoding="utf-8"?>
+<file path=ppt/slides/slide19.xml><?xml version="1.0" encoding="utf-8"?>
 <p:sld xmlns:a="http://schemas.openxmlformats.org/drawingml/2006/main" xmlns:r="http://schemas.openxmlformats.org/officeDocument/2006/relationships" xmlns:p="http://schemas.openxmlformats.org/presentationml/2006/main">
-  <p:cSld name="Slide 16">
+  <p:cSld name="Slide 19">
     <p:bg>
       <p:bgPr>
         <a:solidFill>
@@ -11098,7 +13157,7 @@
         <p:spPr>
           <a:xfrm>
             <a:off x="0" y="0"/>
-            <a:ext cx="9144000" cy="809625"/>
+            <a:ext cx="9144000" cy="679252"/>
           </a:xfrm>
           <a:prstGeom prst="rect">
             <a:avLst/>
@@ -11127,8 +13186,8 @@
         </p:nvSpPr>
         <p:spPr>
           <a:xfrm>
-            <a:off x="381000" y="228600"/>
-            <a:ext cx="8549640" cy="352425"/>
+            <a:off x="381000" y="177701"/>
+            <a:ext cx="8549640" cy="323850"/>
           </a:xfrm>
           <a:prstGeom prst="rect">
             <a:avLst/>
@@ -11144,7 +13203,7 @@
               <a:buNone/>
             </a:pPr>
             <a:r>
-              <a:rPr lang="en-US" sz="2400" b="1" dirty="0">
+              <a:rPr lang="en-US" sz="2200" b="1" dirty="0">
                 <a:solidFill>
                   <a:srgbClr val="FFFFFF"/>
                 </a:solidFill>
@@ -11152,9 +13211,9 @@
                 <a:ea typeface="Arial" pitchFamily="34" charset="-122"/>
                 <a:cs typeface="Arial" pitchFamily="34" charset="-120"/>
               </a:rPr>
-              <a:t>The Token Bottleneck</a:t>
-            </a:r>
-            <a:endParaRPr lang="en-US" sz="2400" dirty="0"/>
+              <a:t>Dataset Creation: From MusicXML to Training Pairs</a:t>
+            </a:r>
+            <a:endParaRPr lang="en-US" sz="2200" dirty="0"/>
           </a:p>
         </p:txBody>
       </p:sp>
@@ -11166,8 +13225,8 @@
         </p:nvSpPr>
         <p:spPr>
           <a:xfrm>
-            <a:off x="381000" y="962025"/>
-            <a:ext cx="4009314" cy="209550"/>
+            <a:off x="381000" y="780752"/>
+            <a:ext cx="5036576" cy="152400"/>
           </a:xfrm>
           <a:prstGeom prst="rect">
             <a:avLst/>
@@ -11181,12 +13240,12 @@
           <a:p>
             <a:pPr algn="l" indent="0" marL="0">
               <a:spcAft>
-                <a:spcPts val="1000"/>
+                <a:spcPts val="600"/>
               </a:spcAft>
               <a:buNone/>
             </a:pPr>
             <a:r>
-              <a:rPr lang="en-US" sz="1400" b="1" dirty="0">
+              <a:rPr lang="en-US" sz="1100" b="1" dirty="0">
                 <a:solidFill>
                   <a:srgbClr val="E41159"/>
                 </a:solidFill>
@@ -11194,9 +13253,9 @@
                 <a:ea typeface="Arial" pitchFamily="34" charset="-122"/>
                 <a:cs typeface="Arial" pitchFamily="34" charset="-120"/>
               </a:rPr>
-              <a:t>The Problem</a:t>
-            </a:r>
-            <a:endParaRPr lang="en-US" sz="1400" dirty="0"/>
+              <a:t>Step 1: Render pages</a:t>
+            </a:r>
+            <a:endParaRPr lang="en-US" sz="1100" dirty="0"/>
           </a:p>
         </p:txBody>
       </p:sp>
@@ -11208,8 +13267,8 @@
         </p:nvSpPr>
         <p:spPr>
           <a:xfrm>
-            <a:off x="381000" y="1298525"/>
-            <a:ext cx="3930700" cy="914102"/>
+            <a:off x="381000" y="1009352"/>
+            <a:ext cx="5036576" cy="266700"/>
           </a:xfrm>
           <a:prstGeom prst="rect">
             <a:avLst/>
@@ -11218,226 +13277,9 @@
           <a:ln/>
         </p:spPr>
         <p:txBody>
-          <a:bodyPr wrap="square" lIns="114300" tIns="0" rIns="0" bIns="0" rtlCol="0" anchor="t"/>
-          <a:lstStyle/>
-          <a:p>
-            <a:pPr algn="l" marL="114300" indent="-114300">
-              <a:spcAft>
-                <a:spcPts val="800"/>
-              </a:spcAft>
-              <a:buSzPct val="100000"/>
-              <a:buChar char="•"/>
-            </a:pPr>
-            <a:r>
-              <a:rPr lang="en-US" sz="1100" dirty="0">
-                <a:solidFill>
-                  <a:srgbClr val="110A29"/>
-                </a:solidFill>
-                <a:latin typeface="Arial" pitchFamily="34" charset="0"/>
-                <a:ea typeface="Arial" pitchFamily="34" charset="-122"/>
-                <a:cs typeface="Arial" pitchFamily="34" charset="-120"/>
-              </a:rPr>
-              <a:t>MusicXML is extremely verbose (~14K tokens per page)</a:t>
-            </a:r>
-            <a:endParaRPr lang="en-US" sz="1100" dirty="0"/>
-          </a:p>
-          <a:p>
-            <a:pPr algn="l" marL="114300" indent="-114300">
-              <a:spcAft>
-                <a:spcPts val="800"/>
-              </a:spcAft>
-              <a:buSzPct val="100000"/>
-              <a:buChar char="•"/>
-            </a:pPr>
-            <a:r>
-              <a:rPr lang="en-US" sz="1100" dirty="0">
-                <a:solidFill>
-                  <a:srgbClr val="110A29"/>
-                </a:solidFill>
-                <a:latin typeface="Arial" pitchFamily="34" charset="0"/>
-                <a:ea typeface="Arial" pitchFamily="34" charset="-122"/>
-                <a:cs typeface="Arial" pitchFamily="34" charset="-120"/>
-              </a:rPr>
-              <a:t>VLM context window: 4,096 tokens</a:t>
-            </a:r>
-            <a:endParaRPr lang="en-US" sz="1100" dirty="0"/>
-          </a:p>
-          <a:p>
-            <a:pPr algn="l" marL="114300" indent="-114300">
-              <a:spcAft>
-                <a:spcPts val="800"/>
-              </a:spcAft>
-              <a:buSzPct val="100000"/>
-              <a:buChar char="•"/>
-            </a:pPr>
-            <a:r>
-              <a:rPr lang="en-US" sz="1100" dirty="0">
-                <a:solidFill>
-                  <a:srgbClr val="110A29"/>
-                </a:solidFill>
-                <a:latin typeface="Arial" pitchFamily="34" charset="0"/>
-                <a:ea typeface="Arial" pitchFamily="34" charset="-122"/>
-                <a:cs typeface="Arial" pitchFamily="34" charset="-120"/>
-              </a:rPr>
-              <a:t>Only 10% of pages fit — models never reach note elements</a:t>
-            </a:r>
-            <a:endParaRPr lang="en-US" sz="1100" dirty="0"/>
-          </a:p>
-          <a:p>
-            <a:pPr algn="l" marL="114300" indent="-114300">
-              <a:spcAft>
-                <a:spcPts val="800"/>
-              </a:spcAft>
-              <a:buSzPct val="100000"/>
-              <a:buChar char="•"/>
-            </a:pPr>
-            <a:r>
-              <a:rPr lang="en-US" sz="1100" dirty="0">
-                <a:solidFill>
-                  <a:srgbClr val="110A29"/>
-                </a:solidFill>
-                <a:latin typeface="Arial" pitchFamily="34" charset="0"/>
-                <a:ea typeface="Arial" pitchFamily="34" charset="-122"/>
-                <a:cs typeface="Arial" pitchFamily="34" charset="-120"/>
-              </a:rPr>
-              <a:t>All models generate headers/metadata, never actual notes</a:t>
-            </a:r>
-            <a:endParaRPr lang="en-US" sz="1100" dirty="0"/>
-          </a:p>
-        </p:txBody>
-      </p:sp>
-      <p:sp>
-        <p:nvSpPr>
-          <p:cNvPr id="6" name="Text 4"/>
-          <p:cNvSpPr/>
-          <p:nvPr/>
-        </p:nvSpPr>
-        <p:spPr>
-          <a:xfrm>
-            <a:off x="4565600" y="962025"/>
-            <a:ext cx="12650" cy="4029075"/>
-          </a:xfrm>
-          <a:prstGeom prst="rect">
-            <a:avLst/>
-          </a:prstGeom>
-          <a:solidFill>
-            <a:srgbClr val="D9D5D2"/>
-          </a:solidFill>
-          <a:ln/>
-        </p:spPr>
-        <p:txBody>
-          <a:bodyPr wrap="square" rtlCol="0" anchor="ctr"/>
-          <a:lstStyle/>
-          <a:p>
-            <a:pPr indent="0" marL="0">
-              <a:buNone/>
-            </a:pPr>
-            <a:endParaRPr lang="en-US" dirty="0"/>
-          </a:p>
-        </p:txBody>
-      </p:sp>
-      <p:sp>
-        <p:nvSpPr>
-          <p:cNvPr id="7" name="Text 5"/>
-          <p:cNvSpPr/>
-          <p:nvPr/>
-        </p:nvSpPr>
-        <p:spPr>
-          <a:xfrm>
-            <a:off x="4832152" y="962025"/>
-            <a:ext cx="4009465" cy="209550"/>
-          </a:xfrm>
-          <a:prstGeom prst="rect">
-            <a:avLst/>
-          </a:prstGeom>
-          <a:noFill/>
-          <a:ln/>
-        </p:spPr>
-        <p:txBody>
           <a:bodyPr wrap="square" lIns="0" tIns="0" rIns="0" bIns="0" rtlCol="0" anchor="t"/>
           <a:lstStyle/>
           <a:p>
-            <a:pPr algn="l" indent="0" marL="0">
-              <a:spcAft>
-                <a:spcPts val="1000"/>
-              </a:spcAft>
-              <a:buNone/>
-            </a:pPr>
-            <a:r>
-              <a:rPr lang="en-US" sz="1400" b="1" dirty="0">
-                <a:solidFill>
-                  <a:srgbClr val="E41159"/>
-                </a:solidFill>
-                <a:latin typeface="Arial" pitchFamily="34" charset="0"/>
-                <a:ea typeface="Arial" pitchFamily="34" charset="-122"/>
-                <a:cs typeface="Arial" pitchFamily="34" charset="-120"/>
-              </a:rPr>
-              <a:t>The Impact</a:t>
-            </a:r>
-            <a:endParaRPr lang="en-US" sz="1400" dirty="0"/>
-          </a:p>
-        </p:txBody>
-      </p:sp>
-      <p:sp>
-        <p:nvSpPr>
-          <p:cNvPr id="8" name="Text 6"/>
-          <p:cNvSpPr/>
-          <p:nvPr/>
-        </p:nvSpPr>
-        <p:spPr>
-          <a:xfrm>
-            <a:off x="4832152" y="1298525"/>
-            <a:ext cx="3930848" cy="914102"/>
-          </a:xfrm>
-          <a:prstGeom prst="rect">
-            <a:avLst/>
-          </a:prstGeom>
-          <a:noFill/>
-          <a:ln/>
-        </p:spPr>
-        <p:txBody>
-          <a:bodyPr wrap="square" lIns="114300" tIns="0" rIns="0" bIns="0" rtlCol="0" anchor="t"/>
-          <a:lstStyle/>
-          <a:p>
-            <a:pPr algn="l" marL="114300" indent="-114300">
-              <a:spcAft>
-                <a:spcPts val="800"/>
-              </a:spcAft>
-              <a:buSzPct val="100000"/>
-              <a:buChar char="•"/>
-            </a:pPr>
-            <a:r>
-              <a:rPr lang="en-US" sz="1100" dirty="0">
-                <a:solidFill>
-                  <a:srgbClr val="110A29"/>
-                </a:solidFill>
-                <a:latin typeface="Arial" pitchFamily="34" charset="0"/>
-                <a:ea typeface="Arial" pitchFamily="34" charset="-122"/>
-                <a:cs typeface="Arial" pitchFamily="34" charset="-120"/>
-              </a:rPr>
-              <a:t>6 models tested with XML targets</a:t>
-            </a:r>
-            <a:endParaRPr lang="en-US" sz="1100" dirty="0"/>
-          </a:p>
-          <a:p>
-            <a:pPr algn="l" marL="114300" indent="-114300">
-              <a:spcAft>
-                <a:spcPts val="800"/>
-              </a:spcAft>
-              <a:buSzPct val="100000"/>
-              <a:buChar char="•"/>
-            </a:pPr>
-            <a:r>
-              <a:rPr lang="en-US" sz="1100" b="1" dirty="0">
-                <a:solidFill>
-                  <a:srgbClr val="110A29"/>
-                </a:solidFill>
-                <a:latin typeface="Arial" pitchFamily="34" charset="0"/>
-                <a:ea typeface="Arial" pitchFamily="34" charset="-122"/>
-                <a:cs typeface="Arial" pitchFamily="34" charset="-120"/>
-              </a:rPr>
-              <a:t>0% pitch accuracy</a:t>
-            </a:r>
             <a:pPr algn="l" indent="0" marL="0">
               <a:spcAft>
                 <a:spcPts val="800"/>
@@ -11445,7 +13287,7 @@
               <a:buNone/>
             </a:pPr>
             <a:r>
-              <a:rPr lang="en-US" sz="1100" dirty="0">
+              <a:rPr lang="en-US" sz="900" dirty="0">
                 <a:solidFill>
                   <a:srgbClr val="110A29"/>
                 </a:solidFill>
@@ -11453,20 +13295,83 @@
                 <a:ea typeface="Arial" pitchFamily="34" charset="-122"/>
                 <a:cs typeface="Arial" pitchFamily="34" charset="-120"/>
               </a:rPr>
-              <a:t> across all models</a:t>
+              <a:t>MusicXML scores from OpenScore corpus rendered to SVG/PNG via LilyPond in Docker. All bar numbers forced visible for later extraction.</a:t>
+            </a:r>
+            <a:endParaRPr lang="en-US" sz="900" dirty="0"/>
+          </a:p>
+        </p:txBody>
+      </p:sp>
+      <p:sp>
+        <p:nvSpPr>
+          <p:cNvPr id="6" name="Text 4"/>
+          <p:cNvSpPr/>
+          <p:nvPr/>
+        </p:nvSpPr>
+        <p:spPr>
+          <a:xfrm>
+            <a:off x="381000" y="1377553"/>
+            <a:ext cx="5036576" cy="152400"/>
+          </a:xfrm>
+          <a:prstGeom prst="rect">
+            <a:avLst/>
+          </a:prstGeom>
+          <a:noFill/>
+          <a:ln/>
+        </p:spPr>
+        <p:txBody>
+          <a:bodyPr wrap="square" lIns="0" tIns="0" rIns="0" bIns="0" rtlCol="0" anchor="t"/>
+          <a:lstStyle/>
+          <a:p>
+            <a:pPr algn="l" indent="0" marL="0">
+              <a:spcAft>
+                <a:spcPts val="600"/>
+              </a:spcAft>
+              <a:buNone/>
+            </a:pPr>
+            <a:r>
+              <a:rPr lang="en-US" sz="1100" b="1" dirty="0">
+                <a:solidFill>
+                  <a:srgbClr val="E41159"/>
+                </a:solidFill>
+                <a:latin typeface="Arial" pitchFamily="34" charset="0"/>
+                <a:ea typeface="Arial" pitchFamily="34" charset="-122"/>
+                <a:cs typeface="Arial" pitchFamily="34" charset="-120"/>
+              </a:rPr>
+              <a:t>Step 2: Extract page boundaries</a:t>
             </a:r>
             <a:endParaRPr lang="en-US" sz="1100" dirty="0"/>
           </a:p>
-          <a:p>
-            <a:pPr algn="l" marL="114300" indent="-114300">
+        </p:txBody>
+      </p:sp>
+      <p:sp>
+        <p:nvSpPr>
+          <p:cNvPr id="7" name="Text 5"/>
+          <p:cNvSpPr/>
+          <p:nvPr/>
+        </p:nvSpPr>
+        <p:spPr>
+          <a:xfrm>
+            <a:off x="381000" y="1606153"/>
+            <a:ext cx="5036576" cy="266700"/>
+          </a:xfrm>
+          <a:prstGeom prst="rect">
+            <a:avLst/>
+          </a:prstGeom>
+          <a:noFill/>
+          <a:ln/>
+        </p:spPr>
+        <p:txBody>
+          <a:bodyPr wrap="square" lIns="0" tIns="0" rIns="0" bIns="0" rtlCol="0" anchor="t"/>
+          <a:lstStyle/>
+          <a:p>
+            <a:pPr algn="l" indent="0" marL="0">
               <a:spcAft>
                 <a:spcPts val="800"/>
               </a:spcAft>
-              <a:buSzPct val="100000"/>
-              <a:buChar char="•"/>
-            </a:pPr>
-            <a:r>
-              <a:rPr lang="en-US" sz="1100" dirty="0">
+              <a:buNone/>
+            </a:pPr>
+            <a:r>
+              <a:rPr lang="en-US" sz="900" dirty="0">
                 <a:solidFill>
                   <a:srgbClr val="110A29"/>
                 </a:solidFill>
@@ -11474,20 +13379,83 @@
                 <a:ea typeface="Arial" pitchFamily="34" charset="-122"/>
                 <a:cs typeface="Arial" pitchFamily="34" charset="-120"/>
               </a:rPr>
-              <a:t>Models learn structure but not musical content</a:t>
+              <a:t>Parse SVG text elements to find bar numbers. Heuristic: most common font size = bar numbers. Filter outliers via consecutive-integer clustering.</a:t>
+            </a:r>
+            <a:endParaRPr lang="en-US" sz="900" dirty="0"/>
+          </a:p>
+        </p:txBody>
+      </p:sp>
+      <p:sp>
+        <p:nvSpPr>
+          <p:cNvPr id="8" name="Text 6"/>
+          <p:cNvSpPr/>
+          <p:nvPr/>
+        </p:nvSpPr>
+        <p:spPr>
+          <a:xfrm>
+            <a:off x="381000" y="1974354"/>
+            <a:ext cx="5036576" cy="152400"/>
+          </a:xfrm>
+          <a:prstGeom prst="rect">
+            <a:avLst/>
+          </a:prstGeom>
+          <a:noFill/>
+          <a:ln/>
+        </p:spPr>
+        <p:txBody>
+          <a:bodyPr wrap="square" lIns="0" tIns="0" rIns="0" bIns="0" rtlCol="0" anchor="t"/>
+          <a:lstStyle/>
+          <a:p>
+            <a:pPr algn="l" indent="0" marL="0">
+              <a:spcAft>
+                <a:spcPts val="600"/>
+              </a:spcAft>
+              <a:buNone/>
+            </a:pPr>
+            <a:r>
+              <a:rPr lang="en-US" sz="1100" b="1" dirty="0">
+                <a:solidFill>
+                  <a:srgbClr val="E41159"/>
+                </a:solidFill>
+                <a:latin typeface="Arial" pitchFamily="34" charset="0"/>
+                <a:ea typeface="Arial" pitchFamily="34" charset="-122"/>
+                <a:cs typeface="Arial" pitchFamily="34" charset="-120"/>
+              </a:rPr>
+              <a:t>Step 3: Slice MusicXML per page</a:t>
             </a:r>
             <a:endParaRPr lang="en-US" sz="1100" dirty="0"/>
           </a:p>
-          <a:p>
-            <a:pPr algn="l" marL="114300" indent="-114300">
+        </p:txBody>
+      </p:sp>
+      <p:sp>
+        <p:nvSpPr>
+          <p:cNvPr id="9" name="Text 7"/>
+          <p:cNvSpPr/>
+          <p:nvPr/>
+        </p:nvSpPr>
+        <p:spPr>
+          <a:xfrm>
+            <a:off x="381000" y="2202954"/>
+            <a:ext cx="5036576" cy="266700"/>
+          </a:xfrm>
+          <a:prstGeom prst="rect">
+            <a:avLst/>
+          </a:prstGeom>
+          <a:noFill/>
+          <a:ln/>
+        </p:spPr>
+        <p:txBody>
+          <a:bodyPr wrap="square" lIns="0" tIns="0" rIns="0" bIns="0" rtlCol="0" anchor="t"/>
+          <a:lstStyle/>
+          <a:p>
+            <a:pPr algn="l" indent="0" marL="0">
               <a:spcAft>
                 <a:spcPts val="800"/>
               </a:spcAft>
-              <a:buSzPct val="100000"/>
-              <a:buChar char="•"/>
-            </a:pPr>
-            <a:r>
-              <a:rPr lang="en-US" sz="1100" dirty="0">
+              <a:buNone/>
+            </a:pPr>
+            <a:r>
+              <a:rPr lang="en-US" sz="900" dirty="0">
                 <a:solidFill>
                   <a:srgbClr val="110A29"/>
                 </a:solidFill>
@@ -11495,15 +13463,96 @@
                 <a:ea typeface="Arial" pitchFamily="34" charset="-122"/>
                 <a:cs typeface="Arial" pitchFamily="34" charset="-120"/>
               </a:rPr>
-              <a:t>Need 12x compression to fit notes in context</a:t>
+              <a:t>music21 extracts measures bar_start to bar_end for each page. Handles pickup bars (measure 0) with auto-offset. Retries with gatherSpanners=False for arpeggio bugs.</a:t>
+            </a:r>
+            <a:endParaRPr lang="en-US" sz="900" dirty="0"/>
+          </a:p>
+        </p:txBody>
+      </p:sp>
+      <p:sp>
+        <p:nvSpPr>
+          <p:cNvPr id="10" name="Text 8"/>
+          <p:cNvSpPr/>
+          <p:nvPr/>
+        </p:nvSpPr>
+        <p:spPr>
+          <a:xfrm>
+            <a:off x="381000" y="2571155"/>
+            <a:ext cx="5036576" cy="152400"/>
+          </a:xfrm>
+          <a:prstGeom prst="rect">
+            <a:avLst/>
+          </a:prstGeom>
+          <a:noFill/>
+          <a:ln/>
+        </p:spPr>
+        <p:txBody>
+          <a:bodyPr wrap="square" lIns="0" tIns="0" rIns="0" bIns="0" rtlCol="0" anchor="t"/>
+          <a:lstStyle/>
+          <a:p>
+            <a:pPr algn="l" indent="0" marL="0">
+              <a:spcAft>
+                <a:spcPts val="600"/>
+              </a:spcAft>
+              <a:buNone/>
+            </a:pPr>
+            <a:r>
+              <a:rPr lang="en-US" sz="1100" b="1" dirty="0">
+                <a:solidFill>
+                  <a:srgbClr val="E41159"/>
+                </a:solidFill>
+                <a:latin typeface="Arial" pitchFamily="34" charset="0"/>
+                <a:ea typeface="Arial" pitchFamily="34" charset="-122"/>
+                <a:cs typeface="Arial" pitchFamily="34" charset="-120"/>
+              </a:rPr>
+              <a:t>Step 4: Push to HuggingFace</a:t>
             </a:r>
             <a:endParaRPr lang="en-US" sz="1100" dirty="0"/>
+          </a:p>
+        </p:txBody>
+      </p:sp>
+      <p:sp>
+        <p:nvSpPr>
+          <p:cNvPr id="11" name="Text 9"/>
+          <p:cNvSpPr/>
+          <p:nvPr/>
+        </p:nvSpPr>
+        <p:spPr>
+          <a:xfrm>
+            <a:off x="381000" y="2799755"/>
+            <a:ext cx="5036576" cy="266700"/>
+          </a:xfrm>
+          <a:prstGeom prst="rect">
+            <a:avLst/>
+          </a:prstGeom>
+          <a:noFill/>
+          <a:ln/>
+        </p:spPr>
+        <p:txBody>
+          <a:bodyPr wrap="square" lIns="0" tIns="0" rIns="0" bIns="0" rtlCol="0" anchor="t"/>
+          <a:lstStyle/>
+          <a:p>
+            <a:pPr algn="l" indent="0" marL="0">
+              <a:buNone/>
+            </a:pPr>
+            <a:r>
+              <a:rPr lang="en-US" sz="900" dirty="0">
+                <a:solidFill>
+                  <a:srgbClr val="110A29"/>
+                </a:solidFill>
+                <a:latin typeface="Arial" pitchFamily="34" charset="0"/>
+                <a:ea typeface="Arial" pitchFamily="34" charset="-122"/>
+                <a:cs typeface="Arial" pitchFamily="34" charset="-120"/>
+              </a:rPr>
+              <a:t>Each row: (PNG image, per-page MusicXML, score_id, page, bars). Streaming-friendly Parquet with corpus column for predicate pushdown.</a:t>
+            </a:r>
+            <a:endParaRPr lang="en-US" sz="900" dirty="0"/>
           </a:p>
         </p:txBody>
       </p:sp>
       <p:pic>
         <p:nvPicPr>
-          <p:cNvPr id="9" name="Image 0" descr="/home/zsi/projects/worktrees/CVlization/vintage-music-sheet/examples/perception/optical_music_recognition/slides-omr-mxc/kungfu-logo.png">    </p:cNvPr>
+          <p:cNvPr id="12" name="Image 0" descr="/home/zsi/projects/worktrees/CVlization/vintage-music-sheet/examples/perception/optical_music_recognition/slides-omr-mxc/openscore_page1_example.png">    </p:cNvPr>
           <p:cNvPicPr>
             <a:picLocks noChangeAspect="1"/>
           </p:cNvPicPr>
@@ -11511,6 +13560,72 @@
         </p:nvPicPr>
         <p:blipFill>
           <a:blip r:embed="rId1"/>
+          <a:stretch>
+            <a:fillRect/>
+          </a:stretch>
+        </p:blipFill>
+        <p:spPr>
+          <a:xfrm>
+            <a:off x="5710684" y="843558"/>
+            <a:ext cx="2812852" cy="3970586"/>
+          </a:xfrm>
+          <a:prstGeom prst="rect">
+            <a:avLst/>
+          </a:prstGeom>
+        </p:spPr>
+      </p:pic>
+      <p:sp>
+        <p:nvSpPr>
+          <p:cNvPr id="13" name="Text 10"/>
+          <p:cNvSpPr/>
+          <p:nvPr/>
+        </p:nvSpPr>
+        <p:spPr>
+          <a:xfrm>
+            <a:off x="6186245" y="4864894"/>
+            <a:ext cx="1861581" cy="114300"/>
+          </a:xfrm>
+          <a:prstGeom prst="rect">
+            <a:avLst/>
+          </a:prstGeom>
+          <a:noFill/>
+          <a:ln/>
+        </p:spPr>
+        <p:txBody>
+          <a:bodyPr wrap="square" lIns="0" tIns="0" rIns="0" bIns="0" rtlCol="0" anchor="t"/>
+          <a:lstStyle/>
+          <a:p>
+            <a:pPr algn="ctr" indent="0" marL="0">
+              <a:spcBef>
+                <a:spcPts val="400"/>
+              </a:spcBef>
+              <a:buNone/>
+            </a:pPr>
+            <a:r>
+              <a:rPr lang="en-US" sz="800" dirty="0">
+                <a:solidFill>
+                  <a:srgbClr val="110A29"/>
+                </a:solidFill>
+                <a:latin typeface="Arial" pitchFamily="34" charset="0"/>
+                <a:ea typeface="Arial" pitchFamily="34" charset="-122"/>
+                <a:cs typeface="Arial" pitchFamily="34" charset="-120"/>
+              </a:rPr>
+              <a:t>lc6583477 p1: "Just for Today" bars 1-29</a:t>
+            </a:r>
+            <a:endParaRPr lang="en-US" sz="800" dirty="0"/>
+          </a:p>
+        </p:txBody>
+      </p:sp>
+      <p:pic>
+        <p:nvPicPr>
+          <p:cNvPr id="14" name="Image 1" descr="/home/zsi/projects/worktrees/CVlization/vintage-music-sheet/examples/perception/optical_music_recognition/slides-omr-mxc/kungfu-logo.png">    </p:cNvPr>
+          <p:cNvPicPr>
+            <a:picLocks noChangeAspect="1"/>
+          </p:cNvPicPr>
+          <p:nvPr/>
+        </p:nvPicPr>
+        <p:blipFill>
+          <a:blip r:embed="rId2"/>
           <a:stretch>
             <a:fillRect/>
           </a:stretch>
@@ -11566,7 +13681,7 @@
         <p:spPr>
           <a:xfrm>
             <a:off x="0" y="0"/>
-            <a:ext cx="9144000" cy="809625"/>
+            <a:ext cx="9144000" cy="679252"/>
           </a:xfrm>
           <a:prstGeom prst="rect">
             <a:avLst/>
@@ -11595,8 +13710,8 @@
         </p:nvSpPr>
         <p:spPr>
           <a:xfrm>
-            <a:off x="381000" y="228600"/>
-            <a:ext cx="8549640" cy="352425"/>
+            <a:off x="381000" y="177701"/>
+            <a:ext cx="8549640" cy="323850"/>
           </a:xfrm>
           <a:prstGeom prst="rect">
             <a:avLst/>
@@ -11612,7 +13727,7 @@
               <a:buNone/>
             </a:pPr>
             <a:r>
-              <a:rPr lang="en-US" sz="2400" b="1" dirty="0">
+              <a:rPr lang="en-US" sz="2200" b="1" dirty="0">
                 <a:solidFill>
                   <a:srgbClr val="FFFFFF"/>
                 </a:solidFill>
@@ -11620,9 +13735,9 @@
                 <a:ea typeface="Arial" pitchFamily="34" charset="-122"/>
                 <a:cs typeface="Arial" pitchFamily="34" charset="-120"/>
               </a:rPr>
-              <a:t>MXC: MusicXML Compact</a:t>
-            </a:r>
-            <a:endParaRPr lang="en-US" sz="2400" dirty="0"/>
+              <a:t>What the Data Looks Like: XML vs MXC</a:t>
+            </a:r>
+            <a:endParaRPr lang="en-US" sz="2200" dirty="0"/>
           </a:p>
         </p:txBody>
       </p:sp>
@@ -11634,8 +13749,8 @@
         </p:nvSpPr>
         <p:spPr>
           <a:xfrm>
-            <a:off x="381000" y="962025"/>
-            <a:ext cx="4009314" cy="209550"/>
+            <a:off x="381000" y="755452"/>
+            <a:ext cx="4184193" cy="142875"/>
           </a:xfrm>
           <a:prstGeom prst="rect">
             <a:avLst/>
@@ -11649,12 +13764,12 @@
           <a:p>
             <a:pPr algn="l" indent="0" marL="0">
               <a:spcAft>
-                <a:spcPts val="1000"/>
+                <a:spcPts val="400"/>
               </a:spcAft>
               <a:buNone/>
             </a:pPr>
             <a:r>
-              <a:rPr lang="en-US" sz="1400" b="1" dirty="0">
+              <a:rPr lang="en-US" sz="1000" b="1" dirty="0">
                 <a:solidFill>
                   <a:srgbClr val="E41159"/>
                 </a:solidFill>
@@ -11662,9 +13777,9 @@
                 <a:ea typeface="Arial" pitchFamily="34" charset="-122"/>
                 <a:cs typeface="Arial" pitchFamily="34" charset="-120"/>
               </a:rPr>
-              <a:t>Design</a:t>
-            </a:r>
-            <a:endParaRPr lang="en-US" sz="1400" dirty="0"/>
+              <a:t>Raw MusicXML (149K chars, ~14K tokens)</a:t>
+            </a:r>
+            <a:endParaRPr lang="en-US" sz="1000" dirty="0"/>
           </a:p>
         </p:txBody>
       </p:sp>
@@ -11676,8 +13791,44 @@
         </p:nvSpPr>
         <p:spPr>
           <a:xfrm>
-            <a:off x="381000" y="1298525"/>
-            <a:ext cx="3930700" cy="838051"/>
+            <a:off x="381000" y="949077"/>
+            <a:ext cx="4102150" cy="1903809"/>
+          </a:xfrm>
+          <a:prstGeom prst="roundRect">
+            <a:avLst>
+              <a:gd name="adj" fmla="val 2668"/>
+            </a:avLst>
+          </a:prstGeom>
+          <a:solidFill>
+            <a:srgbClr val="F5F3F2"/>
+          </a:solidFill>
+          <a:ln w="9525">
+            <a:solidFill>
+              <a:srgbClr val="D9D5D2"/>
+            </a:solidFill>
+          </a:ln>
+        </p:spPr>
+        <p:txBody>
+          <a:bodyPr wrap="square" rtlCol="0" anchor="ctr"/>
+          <a:lstStyle/>
+          <a:p>
+            <a:pPr indent="0" marL="0">
+              <a:buNone/>
+            </a:pPr>
+            <a:endParaRPr lang="en-US" dirty="0"/>
+          </a:p>
+        </p:txBody>
+      </p:sp>
+      <p:sp>
+        <p:nvSpPr>
+          <p:cNvPr id="6" name="Text 4"/>
+          <p:cNvSpPr/>
+          <p:nvPr/>
+        </p:nvSpPr>
+        <p:spPr>
+          <a:xfrm>
+            <a:off x="466725" y="1034802"/>
+            <a:ext cx="4009314" cy="115491"/>
           </a:xfrm>
           <a:prstGeom prst="rect">
             <a:avLst/>
@@ -11686,39 +13837,647 @@
           <a:ln/>
         </p:spPr>
         <p:txBody>
-          <a:bodyPr wrap="square" lIns="114300" tIns="0" rIns="0" bIns="0" rtlCol="0" anchor="t"/>
-          <a:lstStyle/>
-          <a:p>
-            <a:pPr algn="l" marL="114300" indent="-114300">
-              <a:spcAft>
-                <a:spcPts val="700"/>
-              </a:spcAft>
-              <a:buSzPct val="100000"/>
-              <a:buChar char="•"/>
-            </a:pPr>
-            <a:r>
-              <a:rPr lang="en-US" sz="1000" dirty="0">
+          <a:bodyPr wrap="square" lIns="0" tIns="0" rIns="0" bIns="0" rtlCol="0" anchor="t"/>
+          <a:lstStyle/>
+          <a:p>
+            <a:pPr algn="l" indent="0" marL="0">
+              <a:lnSpc>
+                <a:spcPts val="910"/>
+              </a:lnSpc>
+              <a:buNone/>
+            </a:pPr>
+            <a:r>
+              <a:rPr lang="en-US" sz="700" dirty="0">
+                <a:solidFill>
+                  <a:srgbClr val="4421D2"/>
+                </a:solidFill>
+                <a:latin typeface="Courier New" pitchFamily="34" charset="0"/>
+                <a:ea typeface="Courier New" pitchFamily="34" charset="-122"/>
+                <a:cs typeface="Courier New" pitchFamily="34" charset="-120"/>
+              </a:rPr>
+              <a:t>&lt;score-partwise version="4.0"&gt;</a:t>
+            </a:r>
+            <a:endParaRPr lang="en-US" sz="700" dirty="0"/>
+          </a:p>
+        </p:txBody>
+      </p:sp>
+      <p:sp>
+        <p:nvSpPr>
+          <p:cNvPr id="7" name="Text 5"/>
+          <p:cNvSpPr/>
+          <p:nvPr/>
+        </p:nvSpPr>
+        <p:spPr>
+          <a:xfrm>
+            <a:off x="466725" y="1150293"/>
+            <a:ext cx="4009314" cy="115491"/>
+          </a:xfrm>
+          <a:prstGeom prst="rect">
+            <a:avLst/>
+          </a:prstGeom>
+          <a:noFill/>
+          <a:ln/>
+        </p:spPr>
+        <p:txBody>
+          <a:bodyPr wrap="square" lIns="0" tIns="0" rIns="0" bIns="0" rtlCol="0" anchor="t"/>
+          <a:lstStyle/>
+          <a:p>
+            <a:pPr algn="l" indent="0" marL="0">
+              <a:lnSpc>
+                <a:spcPts val="910"/>
+              </a:lnSpc>
+              <a:buNone/>
+            </a:pPr>
+            <a:r>
+              <a:rPr lang="en-US" sz="700" dirty="0">
+                <a:solidFill>
+                  <a:srgbClr val="4421D2"/>
+                </a:solidFill>
+                <a:latin typeface="Courier New" pitchFamily="34" charset="0"/>
+                <a:ea typeface="Courier New" pitchFamily="34" charset="-122"/>
+                <a:cs typeface="Courier New" pitchFamily="34" charset="-120"/>
+              </a:rPr>
+              <a:t>&lt;work&gt;&lt;work-title&gt;Just for Today&lt;/work-title&gt;&lt;/work&gt;</a:t>
+            </a:r>
+            <a:endParaRPr lang="en-US" sz="700" dirty="0"/>
+          </a:p>
+        </p:txBody>
+      </p:sp>
+      <p:sp>
+        <p:nvSpPr>
+          <p:cNvPr id="8" name="Text 6"/>
+          <p:cNvSpPr/>
+          <p:nvPr/>
+        </p:nvSpPr>
+        <p:spPr>
+          <a:xfrm>
+            <a:off x="466725" y="1265783"/>
+            <a:ext cx="4009314" cy="115491"/>
+          </a:xfrm>
+          <a:prstGeom prst="rect">
+            <a:avLst/>
+          </a:prstGeom>
+          <a:noFill/>
+          <a:ln/>
+        </p:spPr>
+        <p:txBody>
+          <a:bodyPr wrap="square" lIns="0" tIns="0" rIns="0" bIns="0" rtlCol="0" anchor="t"/>
+          <a:lstStyle/>
+          <a:p>
+            <a:pPr algn="l" indent="0" marL="0">
+              <a:lnSpc>
+                <a:spcPts val="910"/>
+              </a:lnSpc>
+              <a:buNone/>
+            </a:pPr>
+            <a:r>
+              <a:rPr lang="en-US" sz="700" dirty="0">
+                <a:solidFill>
+                  <a:srgbClr val="4421D2"/>
+                </a:solidFill>
+                <a:latin typeface="Courier New" pitchFamily="34" charset="0"/>
+                <a:ea typeface="Courier New" pitchFamily="34" charset="-122"/>
+                <a:cs typeface="Courier New" pitchFamily="34" charset="-120"/>
+              </a:rPr>
+              <a:t>&lt;identification&gt;</a:t>
+            </a:r>
+            <a:endParaRPr lang="en-US" sz="700" dirty="0"/>
+          </a:p>
+        </p:txBody>
+      </p:sp>
+      <p:sp>
+        <p:nvSpPr>
+          <p:cNvPr id="9" name="Text 7"/>
+          <p:cNvSpPr/>
+          <p:nvPr/>
+        </p:nvSpPr>
+        <p:spPr>
+          <a:xfrm>
+            <a:off x="466725" y="1381274"/>
+            <a:ext cx="4009314" cy="115491"/>
+          </a:xfrm>
+          <a:prstGeom prst="rect">
+            <a:avLst/>
+          </a:prstGeom>
+          <a:noFill/>
+          <a:ln/>
+        </p:spPr>
+        <p:txBody>
+          <a:bodyPr wrap="square" lIns="0" tIns="0" rIns="0" bIns="0" rtlCol="0" anchor="t"/>
+          <a:lstStyle/>
+          <a:p>
+            <a:pPr algn="l" indent="0" marL="0">
+              <a:lnSpc>
+                <a:spcPts val="910"/>
+              </a:lnSpc>
+              <a:buNone/>
+            </a:pPr>
+            <a:r>
+              <a:rPr lang="en-US" sz="700" dirty="0">
+                <a:solidFill>
+                  <a:srgbClr val="4421D2"/>
+                </a:solidFill>
+                <a:latin typeface="Courier New" pitchFamily="34" charset="0"/>
+                <a:ea typeface="Courier New" pitchFamily="34" charset="-122"/>
+                <a:cs typeface="Courier New" pitchFamily="34" charset="-120"/>
+              </a:rPr>
+              <a:t>&lt;creator type="composer"&gt;J.B. Abbott&lt;/creator&gt;</a:t>
+            </a:r>
+            <a:endParaRPr lang="en-US" sz="700" dirty="0"/>
+          </a:p>
+        </p:txBody>
+      </p:sp>
+      <p:sp>
+        <p:nvSpPr>
+          <p:cNvPr id="10" name="Text 8"/>
+          <p:cNvSpPr/>
+          <p:nvPr/>
+        </p:nvSpPr>
+        <p:spPr>
+          <a:xfrm>
+            <a:off x="466725" y="1496764"/>
+            <a:ext cx="4009314" cy="115491"/>
+          </a:xfrm>
+          <a:prstGeom prst="rect">
+            <a:avLst/>
+          </a:prstGeom>
+          <a:noFill/>
+          <a:ln/>
+        </p:spPr>
+        <p:txBody>
+          <a:bodyPr wrap="square" lIns="0" tIns="0" rIns="0" bIns="0" rtlCol="0" anchor="t"/>
+          <a:lstStyle/>
+          <a:p>
+            <a:pPr algn="l" indent="0" marL="0">
+              <a:lnSpc>
+                <a:spcPts val="910"/>
+              </a:lnSpc>
+              <a:buNone/>
+            </a:pPr>
+            <a:r>
+              <a:rPr lang="en-US" sz="700" dirty="0">
+                <a:solidFill>
+                  <a:srgbClr val="4421D2"/>
+                </a:solidFill>
+                <a:latin typeface="Courier New" pitchFamily="34" charset="0"/>
+                <a:ea typeface="Courier New" pitchFamily="34" charset="-122"/>
+                <a:cs typeface="Courier New" pitchFamily="34" charset="-120"/>
+              </a:rPr>
+              <a:t>&lt;encoding&gt;...&lt;/encoding&gt;</a:t>
+            </a:r>
+            <a:endParaRPr lang="en-US" sz="700" dirty="0"/>
+          </a:p>
+        </p:txBody>
+      </p:sp>
+      <p:sp>
+        <p:nvSpPr>
+          <p:cNvPr id="11" name="Text 9"/>
+          <p:cNvSpPr/>
+          <p:nvPr/>
+        </p:nvSpPr>
+        <p:spPr>
+          <a:xfrm>
+            <a:off x="466725" y="1612255"/>
+            <a:ext cx="4009314" cy="115491"/>
+          </a:xfrm>
+          <a:prstGeom prst="rect">
+            <a:avLst/>
+          </a:prstGeom>
+          <a:noFill/>
+          <a:ln/>
+        </p:spPr>
+        <p:txBody>
+          <a:bodyPr wrap="square" lIns="0" tIns="0" rIns="0" bIns="0" rtlCol="0" anchor="t"/>
+          <a:lstStyle/>
+          <a:p>
+            <a:pPr algn="l" indent="0" marL="0">
+              <a:lnSpc>
+                <a:spcPts val="910"/>
+              </a:lnSpc>
+              <a:buNone/>
+            </a:pPr>
+            <a:r>
+              <a:rPr lang="en-US" sz="700" dirty="0">
+                <a:solidFill>
+                  <a:srgbClr val="4421D2"/>
+                </a:solidFill>
+                <a:latin typeface="Courier New" pitchFamily="34" charset="0"/>
+                <a:ea typeface="Courier New" pitchFamily="34" charset="-122"/>
+                <a:cs typeface="Courier New" pitchFamily="34" charset="-120"/>
+              </a:rPr>
+              <a:t>&lt;/identification&gt;</a:t>
+            </a:r>
+            <a:endParaRPr lang="en-US" sz="700" dirty="0"/>
+          </a:p>
+        </p:txBody>
+      </p:sp>
+      <p:sp>
+        <p:nvSpPr>
+          <p:cNvPr id="12" name="Text 10"/>
+          <p:cNvSpPr/>
+          <p:nvPr/>
+        </p:nvSpPr>
+        <p:spPr>
+          <a:xfrm>
+            <a:off x="466725" y="1727746"/>
+            <a:ext cx="4009314" cy="115491"/>
+          </a:xfrm>
+          <a:prstGeom prst="rect">
+            <a:avLst/>
+          </a:prstGeom>
+          <a:noFill/>
+          <a:ln/>
+        </p:spPr>
+        <p:txBody>
+          <a:bodyPr wrap="square" lIns="0" tIns="0" rIns="0" bIns="0" rtlCol="0" anchor="t"/>
+          <a:lstStyle/>
+          <a:p>
+            <a:pPr algn="l" indent="0" marL="0">
+              <a:lnSpc>
+                <a:spcPts val="910"/>
+              </a:lnSpc>
+              <a:buNone/>
+            </a:pPr>
+            <a:r>
+              <a:rPr lang="en-US" sz="700" dirty="0">
+                <a:solidFill>
+                  <a:srgbClr val="4421D2"/>
+                </a:solidFill>
+                <a:latin typeface="Courier New" pitchFamily="34" charset="0"/>
+                <a:ea typeface="Courier New" pitchFamily="34" charset="-122"/>
+                <a:cs typeface="Courier New" pitchFamily="34" charset="-120"/>
+              </a:rPr>
+              <a:t>&lt;defaults&gt;...&lt;/defaults&gt;</a:t>
+            </a:r>
+            <a:endParaRPr lang="en-US" sz="700" dirty="0"/>
+          </a:p>
+        </p:txBody>
+      </p:sp>
+      <p:sp>
+        <p:nvSpPr>
+          <p:cNvPr id="13" name="Text 11"/>
+          <p:cNvSpPr/>
+          <p:nvPr/>
+        </p:nvSpPr>
+        <p:spPr>
+          <a:xfrm>
+            <a:off x="466725" y="1843236"/>
+            <a:ext cx="4009314" cy="115491"/>
+          </a:xfrm>
+          <a:prstGeom prst="rect">
+            <a:avLst/>
+          </a:prstGeom>
+          <a:noFill/>
+          <a:ln/>
+        </p:spPr>
+        <p:txBody>
+          <a:bodyPr wrap="square" lIns="0" tIns="0" rIns="0" bIns="0" rtlCol="0" anchor="t"/>
+          <a:lstStyle/>
+          <a:p>
+            <a:pPr algn="l" indent="0" marL="0">
+              <a:lnSpc>
+                <a:spcPts val="910"/>
+              </a:lnSpc>
+              <a:buNone/>
+            </a:pPr>
+            <a:r>
+              <a:rPr lang="en-US" sz="700" dirty="0">
+                <a:solidFill>
+                  <a:srgbClr val="4421D2"/>
+                </a:solidFill>
+                <a:latin typeface="Courier New" pitchFamily="34" charset="0"/>
+                <a:ea typeface="Courier New" pitchFamily="34" charset="-122"/>
+                <a:cs typeface="Courier New" pitchFamily="34" charset="-120"/>
+              </a:rPr>
+              <a:t>&lt;part-list&gt;</a:t>
+            </a:r>
+            <a:endParaRPr lang="en-US" sz="700" dirty="0"/>
+          </a:p>
+        </p:txBody>
+      </p:sp>
+      <p:sp>
+        <p:nvSpPr>
+          <p:cNvPr id="14" name="Text 12"/>
+          <p:cNvSpPr/>
+          <p:nvPr/>
+        </p:nvSpPr>
+        <p:spPr>
+          <a:xfrm>
+            <a:off x="466725" y="1958727"/>
+            <a:ext cx="4009314" cy="115491"/>
+          </a:xfrm>
+          <a:prstGeom prst="rect">
+            <a:avLst/>
+          </a:prstGeom>
+          <a:noFill/>
+          <a:ln/>
+        </p:spPr>
+        <p:txBody>
+          <a:bodyPr wrap="square" lIns="0" tIns="0" rIns="0" bIns="0" rtlCol="0" anchor="t"/>
+          <a:lstStyle/>
+          <a:p>
+            <a:pPr algn="l" indent="0" marL="0">
+              <a:lnSpc>
+                <a:spcPts val="910"/>
+              </a:lnSpc>
+              <a:buNone/>
+            </a:pPr>
+            <a:r>
+              <a:rPr lang="en-US" sz="700" dirty="0">
+                <a:solidFill>
+                  <a:srgbClr val="4421D2"/>
+                </a:solidFill>
+                <a:latin typeface="Courier New" pitchFamily="34" charset="0"/>
+                <a:ea typeface="Courier New" pitchFamily="34" charset="-122"/>
+                <a:cs typeface="Courier New" pitchFamily="34" charset="-120"/>
+              </a:rPr>
+              <a:t>&lt;score-part id="P1"&gt;</a:t>
+            </a:r>
+            <a:endParaRPr lang="en-US" sz="700" dirty="0"/>
+          </a:p>
+        </p:txBody>
+      </p:sp>
+      <p:sp>
+        <p:nvSpPr>
+          <p:cNvPr id="15" name="Text 13"/>
+          <p:cNvSpPr/>
+          <p:nvPr/>
+        </p:nvSpPr>
+        <p:spPr>
+          <a:xfrm>
+            <a:off x="466725" y="2074218"/>
+            <a:ext cx="4009314" cy="115491"/>
+          </a:xfrm>
+          <a:prstGeom prst="rect">
+            <a:avLst/>
+          </a:prstGeom>
+          <a:noFill/>
+          <a:ln/>
+        </p:spPr>
+        <p:txBody>
+          <a:bodyPr wrap="square" lIns="0" tIns="0" rIns="0" bIns="0" rtlCol="0" anchor="t"/>
+          <a:lstStyle/>
+          <a:p>
+            <a:pPr algn="l" indent="0" marL="0">
+              <a:lnSpc>
+                <a:spcPts val="910"/>
+              </a:lnSpc>
+              <a:buNone/>
+            </a:pPr>
+            <a:r>
+              <a:rPr lang="en-US" sz="700" dirty="0">
+                <a:solidFill>
+                  <a:srgbClr val="4421D2"/>
+                </a:solidFill>
+                <a:latin typeface="Courier New" pitchFamily="34" charset="0"/>
+                <a:ea typeface="Courier New" pitchFamily="34" charset="-122"/>
+                <a:cs typeface="Courier New" pitchFamily="34" charset="-120"/>
+              </a:rPr>
+              <a:t>&lt;part-name&gt;Voice&lt;/part-name&gt;</a:t>
+            </a:r>
+            <a:endParaRPr lang="en-US" sz="700" dirty="0"/>
+          </a:p>
+        </p:txBody>
+      </p:sp>
+      <p:sp>
+        <p:nvSpPr>
+          <p:cNvPr id="16" name="Text 14"/>
+          <p:cNvSpPr/>
+          <p:nvPr/>
+        </p:nvSpPr>
+        <p:spPr>
+          <a:xfrm>
+            <a:off x="466725" y="2189708"/>
+            <a:ext cx="4009314" cy="115491"/>
+          </a:xfrm>
+          <a:prstGeom prst="rect">
+            <a:avLst/>
+          </a:prstGeom>
+          <a:noFill/>
+          <a:ln/>
+        </p:spPr>
+        <p:txBody>
+          <a:bodyPr wrap="square" lIns="0" tIns="0" rIns="0" bIns="0" rtlCol="0" anchor="t"/>
+          <a:lstStyle/>
+          <a:p>
+            <a:pPr algn="l" indent="0" marL="0">
+              <a:lnSpc>
+                <a:spcPts val="910"/>
+              </a:lnSpc>
+              <a:buNone/>
+            </a:pPr>
+            <a:r>
+              <a:rPr lang="en-US" sz="700" dirty="0">
+                <a:solidFill>
+                  <a:srgbClr val="4421D2"/>
+                </a:solidFill>
+                <a:latin typeface="Courier New" pitchFamily="34" charset="0"/>
+                <a:ea typeface="Courier New" pitchFamily="34" charset="-122"/>
+                <a:cs typeface="Courier New" pitchFamily="34" charset="-120"/>
+              </a:rPr>
+              <a:t>&lt;score-instrument id="Ic30e..."&gt;</a:t>
+            </a:r>
+            <a:endParaRPr lang="en-US" sz="700" dirty="0"/>
+          </a:p>
+        </p:txBody>
+      </p:sp>
+      <p:sp>
+        <p:nvSpPr>
+          <p:cNvPr id="17" name="Text 15"/>
+          <p:cNvSpPr/>
+          <p:nvPr/>
+        </p:nvSpPr>
+        <p:spPr>
+          <a:xfrm>
+            <a:off x="466725" y="2305199"/>
+            <a:ext cx="4009314" cy="115491"/>
+          </a:xfrm>
+          <a:prstGeom prst="rect">
+            <a:avLst/>
+          </a:prstGeom>
+          <a:noFill/>
+          <a:ln/>
+        </p:spPr>
+        <p:txBody>
+          <a:bodyPr wrap="square" lIns="0" tIns="0" rIns="0" bIns="0" rtlCol="0" anchor="t"/>
+          <a:lstStyle/>
+          <a:p>
+            <a:pPr algn="l" indent="0" marL="0">
+              <a:lnSpc>
+                <a:spcPts val="910"/>
+              </a:lnSpc>
+              <a:buNone/>
+            </a:pPr>
+            <a:r>
+              <a:rPr lang="en-US" sz="700" dirty="0">
+                <a:solidFill>
+                  <a:srgbClr val="4421D2"/>
+                </a:solidFill>
+                <a:latin typeface="Courier New" pitchFamily="34" charset="0"/>
+                <a:ea typeface="Courier New" pitchFamily="34" charset="-122"/>
+                <a:cs typeface="Courier New" pitchFamily="34" charset="-120"/>
+              </a:rPr>
+              <a:t>&lt;instrument-name&gt;Voice&lt;/instrument-name&gt;</a:t>
+            </a:r>
+            <a:endParaRPr lang="en-US" sz="700" dirty="0"/>
+          </a:p>
+        </p:txBody>
+      </p:sp>
+      <p:sp>
+        <p:nvSpPr>
+          <p:cNvPr id="18" name="Text 16"/>
+          <p:cNvSpPr/>
+          <p:nvPr/>
+        </p:nvSpPr>
+        <p:spPr>
+          <a:xfrm>
+            <a:off x="466725" y="2420689"/>
+            <a:ext cx="4009314" cy="115491"/>
+          </a:xfrm>
+          <a:prstGeom prst="rect">
+            <a:avLst/>
+          </a:prstGeom>
+          <a:noFill/>
+          <a:ln/>
+        </p:spPr>
+        <p:txBody>
+          <a:bodyPr wrap="square" lIns="0" tIns="0" rIns="0" bIns="0" rtlCol="0" anchor="t"/>
+          <a:lstStyle/>
+          <a:p>
+            <a:pPr algn="l" indent="0" marL="0">
+              <a:lnSpc>
+                <a:spcPts val="910"/>
+              </a:lnSpc>
+              <a:buNone/>
+            </a:pPr>
+            <a:r>
+              <a:rPr lang="en-US" sz="700" dirty="0">
+                <a:solidFill>
+                  <a:srgbClr val="4421D2"/>
+                </a:solidFill>
+                <a:latin typeface="Courier New" pitchFamily="34" charset="0"/>
+                <a:ea typeface="Courier New" pitchFamily="34" charset="-122"/>
+                <a:cs typeface="Courier New" pitchFamily="34" charset="-120"/>
+              </a:rPr>
+              <a:t>&lt;/score-instrument&gt;</a:t>
+            </a:r>
+            <a:endParaRPr lang="en-US" sz="700" dirty="0"/>
+          </a:p>
+        </p:txBody>
+      </p:sp>
+      <p:sp>
+        <p:nvSpPr>
+          <p:cNvPr id="19" name="Text 17"/>
+          <p:cNvSpPr/>
+          <p:nvPr/>
+        </p:nvSpPr>
+        <p:spPr>
+          <a:xfrm>
+            <a:off x="466725" y="2536180"/>
+            <a:ext cx="4009314" cy="115491"/>
+          </a:xfrm>
+          <a:prstGeom prst="rect">
+            <a:avLst/>
+          </a:prstGeom>
+          <a:noFill/>
+          <a:ln/>
+        </p:spPr>
+        <p:txBody>
+          <a:bodyPr wrap="square" lIns="0" tIns="0" rIns="0" bIns="0" rtlCol="0" anchor="t"/>
+          <a:lstStyle/>
+          <a:p>
+            <a:pPr algn="l" indent="0" marL="0">
+              <a:lnSpc>
+                <a:spcPts val="910"/>
+              </a:lnSpc>
+              <a:buNone/>
+            </a:pPr>
+            <a:r>
+              <a:rPr lang="en-US" sz="700" dirty="0">
+                <a:solidFill>
+                  <a:srgbClr val="4421D2"/>
+                </a:solidFill>
+                <a:latin typeface="Courier New" pitchFamily="34" charset="0"/>
+                <a:ea typeface="Courier New" pitchFamily="34" charset="-122"/>
+                <a:cs typeface="Courier New" pitchFamily="34" charset="-120"/>
+              </a:rPr>
+              <a:t>&lt;midi-instrument id="Ic30e..."&gt;</a:t>
+            </a:r>
+            <a:endParaRPr lang="en-US" sz="700" dirty="0"/>
+          </a:p>
+        </p:txBody>
+      </p:sp>
+      <p:sp>
+        <p:nvSpPr>
+          <p:cNvPr id="20" name="Text 18"/>
+          <p:cNvSpPr/>
+          <p:nvPr/>
+        </p:nvSpPr>
+        <p:spPr>
+          <a:xfrm>
+            <a:off x="466725" y="2651671"/>
+            <a:ext cx="4009314" cy="115491"/>
+          </a:xfrm>
+          <a:prstGeom prst="rect">
+            <a:avLst/>
+          </a:prstGeom>
+          <a:noFill/>
+          <a:ln/>
+        </p:spPr>
+        <p:txBody>
+          <a:bodyPr wrap="square" lIns="0" tIns="0" rIns="0" bIns="0" rtlCol="0" anchor="t"/>
+          <a:lstStyle/>
+          <a:p>
+            <a:pPr algn="l" indent="0" marL="0">
+              <a:lnSpc>
+                <a:spcPts val="910"/>
+              </a:lnSpc>
+              <a:buNone/>
+            </a:pPr>
+            <a:r>
+              <a:rPr lang="en-US" sz="700" dirty="0">
                 <a:solidFill>
                   <a:srgbClr val="110A29"/>
                 </a:solidFill>
-                <a:latin typeface="Arial" pitchFamily="34" charset="0"/>
-                <a:ea typeface="Arial" pitchFamily="34" charset="-122"/>
-                <a:cs typeface="Arial" pitchFamily="34" charset="-120"/>
-              </a:rPr>
-              <a:t>Line-based encoding: one note = one line</a:t>
-            </a:r>
-            <a:endParaRPr lang="en-US" sz="1000" dirty="0"/>
-          </a:p>
-          <a:p>
-            <a:pPr algn="l" marL="114300" indent="-114300">
-              <a:spcAft>
-                <a:spcPts val="700"/>
-              </a:spcAft>
-              <a:buSzPct val="100000"/>
-              <a:buChar char="•"/>
-            </a:pPr>
-            <a:r>
-              <a:rPr lang="en-US" sz="1000" b="1" dirty="0">
+                <a:latin typeface="Courier New" pitchFamily="34" charset="0"/>
+                <a:ea typeface="Courier New" pitchFamily="34" charset="-122"/>
+                <a:cs typeface="Courier New" pitchFamily="34" charset="-120"/>
+              </a:rPr>
+              <a:t>... (149,709 chars total)</a:t>
+            </a:r>
+            <a:endParaRPr lang="en-US" sz="700" dirty="0"/>
+          </a:p>
+        </p:txBody>
+      </p:sp>
+      <p:sp>
+        <p:nvSpPr>
+          <p:cNvPr id="21" name="Text 19"/>
+          <p:cNvSpPr/>
+          <p:nvPr/>
+        </p:nvSpPr>
+        <p:spPr>
+          <a:xfrm>
+            <a:off x="381000" y="2903637"/>
+            <a:ext cx="4184193" cy="114300"/>
+          </a:xfrm>
+          <a:prstGeom prst="rect">
+            <a:avLst/>
+          </a:prstGeom>
+          <a:noFill/>
+          <a:ln/>
+        </p:spPr>
+        <p:txBody>
+          <a:bodyPr wrap="square" lIns="0" tIns="0" rIns="0" bIns="0" rtlCol="0" anchor="t"/>
+          <a:lstStyle/>
+          <a:p>
+            <a:pPr algn="l" indent="0" marL="0">
+              <a:spcBef>
+                <a:spcPts val="400"/>
+              </a:spcBef>
+              <a:buNone/>
+            </a:pPr>
+            <a:r>
+              <a:rPr lang="en-US" sz="800" dirty="0">
                 <a:solidFill>
                   <a:srgbClr val="110A29"/>
                 </a:solidFill>
@@ -11726,37 +14485,749 @@
                 <a:ea typeface="Arial" pitchFamily="34" charset="-122"/>
                 <a:cs typeface="Arial" pitchFamily="34" charset="-120"/>
               </a:rPr>
-              <a:t>N C4 q 10080 su L1:s:Lord,</a:t>
-            </a:r>
+              <a:t>Only ~10% of pages fit in 4K token context window. Models never see the actual notes.</a:t>
+            </a:r>
+            <a:endParaRPr lang="en-US" sz="800" dirty="0"/>
+          </a:p>
+        </p:txBody>
+      </p:sp>
+      <p:sp>
+        <p:nvSpPr>
+          <p:cNvPr id="22" name="Text 20"/>
+          <p:cNvSpPr/>
+          <p:nvPr/>
+        </p:nvSpPr>
+        <p:spPr>
+          <a:xfrm>
+            <a:off x="4660850" y="755452"/>
+            <a:ext cx="4184193" cy="142875"/>
+          </a:xfrm>
+          <a:prstGeom prst="rect">
+            <a:avLst/>
+          </a:prstGeom>
+          <a:noFill/>
+          <a:ln/>
+        </p:spPr>
+        <p:txBody>
+          <a:bodyPr wrap="square" lIns="0" tIns="0" rIns="0" bIns="0" rtlCol="0" anchor="t"/>
+          <a:lstStyle/>
+          <a:p>
             <a:pPr algn="l" indent="0" marL="0">
               <a:spcAft>
-                <a:spcPts val="700"/>
+                <a:spcPts val="400"/>
               </a:spcAft>
               <a:buNone/>
             </a:pPr>
             <a:r>
-              <a:rPr lang="en-US" sz="1000" dirty="0">
+              <a:rPr lang="en-US" sz="1000" b="1" dirty="0">
+                <a:solidFill>
+                  <a:srgbClr val="E41159"/>
+                </a:solidFill>
+                <a:latin typeface="Arial" pitchFamily="34" charset="0"/>
+                <a:ea typeface="Arial" pitchFamily="34" charset="-122"/>
+                <a:cs typeface="Arial" pitchFamily="34" charset="-120"/>
+              </a:rPr>
+              <a:t>MXC Compact (15K chars, ~1.2K tokens)</a:t>
+            </a:r>
+            <a:endParaRPr lang="en-US" sz="1000" dirty="0"/>
+          </a:p>
+        </p:txBody>
+      </p:sp>
+      <p:sp>
+        <p:nvSpPr>
+          <p:cNvPr id="23" name="Text 21"/>
+          <p:cNvSpPr/>
+          <p:nvPr/>
+        </p:nvSpPr>
+        <p:spPr>
+          <a:xfrm>
+            <a:off x="4660850" y="949077"/>
+            <a:ext cx="4102150" cy="1903809"/>
+          </a:xfrm>
+          <a:prstGeom prst="roundRect">
+            <a:avLst>
+              <a:gd name="adj" fmla="val 2668"/>
+            </a:avLst>
+          </a:prstGeom>
+          <a:solidFill>
+            <a:srgbClr val="F5F3F2"/>
+          </a:solidFill>
+          <a:ln w="9525">
+            <a:solidFill>
+              <a:srgbClr val="D9D5D2"/>
+            </a:solidFill>
+          </a:ln>
+        </p:spPr>
+        <p:txBody>
+          <a:bodyPr wrap="square" rtlCol="0" anchor="ctr"/>
+          <a:lstStyle/>
+          <a:p>
+            <a:pPr indent="0" marL="0">
+              <a:buNone/>
+            </a:pPr>
+            <a:endParaRPr lang="en-US" dirty="0"/>
+          </a:p>
+        </p:txBody>
+      </p:sp>
+      <p:sp>
+        <p:nvSpPr>
+          <p:cNvPr id="24" name="Text 22"/>
+          <p:cNvSpPr/>
+          <p:nvPr/>
+        </p:nvSpPr>
+        <p:spPr>
+          <a:xfrm>
+            <a:off x="4746575" y="1034802"/>
+            <a:ext cx="4009314" cy="115491"/>
+          </a:xfrm>
+          <a:prstGeom prst="rect">
+            <a:avLst/>
+          </a:prstGeom>
+          <a:noFill/>
+          <a:ln/>
+        </p:spPr>
+        <p:txBody>
+          <a:bodyPr wrap="square" lIns="0" tIns="0" rIns="0" bIns="0" rtlCol="0" anchor="t"/>
+          <a:lstStyle/>
+          <a:p>
+            <a:pPr algn="l" indent="0" marL="0">
+              <a:lnSpc>
+                <a:spcPts val="910"/>
+              </a:lnSpc>
+              <a:buNone/>
+            </a:pPr>
+            <a:r>
+              <a:rPr lang="en-US" sz="700" dirty="0">
+                <a:solidFill>
+                  <a:srgbClr val="4421D2"/>
+                </a:solidFill>
+                <a:latin typeface="Courier New" pitchFamily="34" charset="0"/>
+                <a:ea typeface="Courier New" pitchFamily="34" charset="-122"/>
+                <a:cs typeface="Courier New" pitchFamily="34" charset="-120"/>
+              </a:rPr>
+              <a:t>header work-title="Just for Today"</a:t>
+            </a:r>
+            <a:endParaRPr lang="en-US" sz="700" dirty="0"/>
+          </a:p>
+        </p:txBody>
+      </p:sp>
+      <p:sp>
+        <p:nvSpPr>
+          <p:cNvPr id="25" name="Text 23"/>
+          <p:cNvSpPr/>
+          <p:nvPr/>
+        </p:nvSpPr>
+        <p:spPr>
+          <a:xfrm>
+            <a:off x="4746575" y="1150293"/>
+            <a:ext cx="4009314" cy="115491"/>
+          </a:xfrm>
+          <a:prstGeom prst="rect">
+            <a:avLst/>
+          </a:prstGeom>
+          <a:noFill/>
+          <a:ln/>
+        </p:spPr>
+        <p:txBody>
+          <a:bodyPr wrap="square" lIns="0" tIns="0" rIns="0" bIns="0" rtlCol="0" anchor="t"/>
+          <a:lstStyle/>
+          <a:p>
+            <a:pPr algn="l" indent="0" marL="0">
+              <a:lnSpc>
+                <a:spcPts val="910"/>
+              </a:lnSpc>
+              <a:buNone/>
+            </a:pPr>
+            <a:r>
+              <a:rPr lang="en-US" sz="700" dirty="0">
+                <a:solidFill>
+                  <a:srgbClr val="4421D2"/>
+                </a:solidFill>
+                <a:latin typeface="Courier New" pitchFamily="34" charset="0"/>
+                <a:ea typeface="Courier New" pitchFamily="34" charset="-122"/>
+                <a:cs typeface="Courier New" pitchFamily="34" charset="-120"/>
+              </a:rPr>
+              <a:t>header composer="Jane Bingham Abbott"</a:t>
+            </a:r>
+            <a:endParaRPr lang="en-US" sz="700" dirty="0"/>
+          </a:p>
+        </p:txBody>
+      </p:sp>
+      <p:sp>
+        <p:nvSpPr>
+          <p:cNvPr id="26" name="Text 24"/>
+          <p:cNvSpPr/>
+          <p:nvPr/>
+        </p:nvSpPr>
+        <p:spPr>
+          <a:xfrm>
+            <a:off x="4746575" y="1265783"/>
+            <a:ext cx="4009314" cy="115491"/>
+          </a:xfrm>
+          <a:prstGeom prst="rect">
+            <a:avLst/>
+          </a:prstGeom>
+          <a:noFill/>
+          <a:ln/>
+        </p:spPr>
+        <p:txBody>
+          <a:bodyPr wrap="square" lIns="0" tIns="0" rIns="0" bIns="0" rtlCol="0" anchor="t"/>
+          <a:lstStyle/>
+          <a:p>
+            <a:pPr algn="l" indent="0" marL="0">
+              <a:lnSpc>
+                <a:spcPts val="910"/>
+              </a:lnSpc>
+              <a:buNone/>
+            </a:pPr>
+            <a:r>
+              <a:rPr lang="en-US" sz="700" dirty="0">
+                <a:solidFill>
+                  <a:srgbClr val="4421D2"/>
+                </a:solidFill>
+                <a:latin typeface="Courier New" pitchFamily="34" charset="0"/>
+                <a:ea typeface="Courier New" pitchFamily="34" charset="-122"/>
+                <a:cs typeface="Courier New" pitchFamily="34" charset="-120"/>
+              </a:rPr>
+              <a:t>P1 Voice Ob</a:t>
+            </a:r>
+            <a:endParaRPr lang="en-US" sz="700" dirty="0"/>
+          </a:p>
+        </p:txBody>
+      </p:sp>
+      <p:sp>
+        <p:nvSpPr>
+          <p:cNvPr id="27" name="Text 25"/>
+          <p:cNvSpPr/>
+          <p:nvPr/>
+        </p:nvSpPr>
+        <p:spPr>
+          <a:xfrm>
+            <a:off x="4746575" y="1381274"/>
+            <a:ext cx="4009314" cy="115491"/>
+          </a:xfrm>
+          <a:prstGeom prst="rect">
+            <a:avLst/>
+          </a:prstGeom>
+          <a:noFill/>
+          <a:ln/>
+        </p:spPr>
+        <p:txBody>
+          <a:bodyPr wrap="square" lIns="0" tIns="0" rIns="0" bIns="0" rtlCol="0" anchor="t"/>
+          <a:lstStyle/>
+          <a:p>
+            <a:pPr algn="l" indent="0" marL="0">
+              <a:lnSpc>
+                <a:spcPts val="910"/>
+              </a:lnSpc>
+              <a:buNone/>
+            </a:pPr>
+            <a:r>
+              <a:rPr lang="en-US" sz="700" dirty="0">
+                <a:solidFill>
+                  <a:srgbClr val="4421D2"/>
+                </a:solidFill>
+                <a:latin typeface="Courier New" pitchFamily="34" charset="0"/>
+                <a:ea typeface="Courier New" pitchFamily="34" charset="-122"/>
+                <a:cs typeface="Courier New" pitchFamily="34" charset="-120"/>
+              </a:rPr>
+              <a:t>P2 Piano Pno</a:t>
+            </a:r>
+            <a:endParaRPr lang="en-US" sz="700" dirty="0"/>
+          </a:p>
+        </p:txBody>
+      </p:sp>
+      <p:sp>
+        <p:nvSpPr>
+          <p:cNvPr id="28" name="Text 26"/>
+          <p:cNvSpPr/>
+          <p:nvPr/>
+        </p:nvSpPr>
+        <p:spPr>
+          <a:xfrm>
+            <a:off x="4746575" y="1496764"/>
+            <a:ext cx="4009314" cy="115491"/>
+          </a:xfrm>
+          <a:prstGeom prst="rect">
+            <a:avLst/>
+          </a:prstGeom>
+          <a:noFill/>
+          <a:ln/>
+        </p:spPr>
+        <p:txBody>
+          <a:bodyPr wrap="square" lIns="0" tIns="0" rIns="0" bIns="0" rtlCol="0" anchor="t"/>
+          <a:lstStyle/>
+          <a:p>
+            <a:pPr algn="l" indent="0" marL="0">
+              <a:lnSpc>
+                <a:spcPts val="910"/>
+              </a:lnSpc>
+              <a:buNone/>
+            </a:pPr>
+            <a:r>
+              <a:rPr lang="en-US" sz="700" dirty="0">
+                <a:solidFill>
+                  <a:srgbClr val="4421D2"/>
+                </a:solidFill>
+                <a:latin typeface="Courier New" pitchFamily="34" charset="0"/>
+                <a:ea typeface="Courier New" pitchFamily="34" charset="-122"/>
+                <a:cs typeface="Courier New" pitchFamily="34" charset="-120"/>
+              </a:rPr>
+              <a:t>---</a:t>
+            </a:r>
+            <a:endParaRPr lang="en-US" sz="700" dirty="0"/>
+          </a:p>
+        </p:txBody>
+      </p:sp>
+      <p:sp>
+        <p:nvSpPr>
+          <p:cNvPr id="29" name="Text 27"/>
+          <p:cNvSpPr/>
+          <p:nvPr/>
+        </p:nvSpPr>
+        <p:spPr>
+          <a:xfrm>
+            <a:off x="4746575" y="1612255"/>
+            <a:ext cx="4009314" cy="115491"/>
+          </a:xfrm>
+          <a:prstGeom prst="rect">
+            <a:avLst/>
+          </a:prstGeom>
+          <a:noFill/>
+          <a:ln/>
+        </p:spPr>
+        <p:txBody>
+          <a:bodyPr wrap="square" lIns="0" tIns="0" rIns="0" bIns="0" rtlCol="0" anchor="t"/>
+          <a:lstStyle/>
+          <a:p>
+            <a:pPr algn="l" indent="0" marL="0">
+              <a:lnSpc>
+                <a:spcPts val="910"/>
+              </a:lnSpc>
+              <a:buNone/>
+            </a:pPr>
+            <a:r>
+              <a:rPr lang="en-US" sz="700" dirty="0">
+                <a:solidFill>
+                  <a:srgbClr val="4421D2"/>
+                </a:solidFill>
+                <a:latin typeface="Courier New" pitchFamily="34" charset="0"/>
+                <a:ea typeface="Courier New" pitchFamily="34" charset="-122"/>
+                <a:cs typeface="Courier New" pitchFamily="34" charset="-120"/>
+              </a:rPr>
+              <a:t>P1</a:t>
+            </a:r>
+            <a:endParaRPr lang="en-US" sz="700" dirty="0"/>
+          </a:p>
+        </p:txBody>
+      </p:sp>
+      <p:sp>
+        <p:nvSpPr>
+          <p:cNvPr id="30" name="Text 28"/>
+          <p:cNvSpPr/>
+          <p:nvPr/>
+        </p:nvSpPr>
+        <p:spPr>
+          <a:xfrm>
+            <a:off x="4746575" y="1727746"/>
+            <a:ext cx="4009314" cy="115491"/>
+          </a:xfrm>
+          <a:prstGeom prst="rect">
+            <a:avLst/>
+          </a:prstGeom>
+          <a:noFill/>
+          <a:ln/>
+        </p:spPr>
+        <p:txBody>
+          <a:bodyPr wrap="square" lIns="0" tIns="0" rIns="0" bIns="0" rtlCol="0" anchor="t"/>
+          <a:lstStyle/>
+          <a:p>
+            <a:pPr algn="l" indent="0" marL="0">
+              <a:lnSpc>
+                <a:spcPts val="910"/>
+              </a:lnSpc>
+              <a:buNone/>
+            </a:pPr>
+            <a:r>
+              <a:rPr lang="en-US" sz="700" dirty="0">
+                <a:solidFill>
+                  <a:srgbClr val="4421D2"/>
+                </a:solidFill>
+                <a:latin typeface="Courier New" pitchFamily="34" charset="0"/>
+                <a:ea typeface="Courier New" pitchFamily="34" charset="-122"/>
+                <a:cs typeface="Courier New" pitchFamily="34" charset="-120"/>
+              </a:rPr>
+              <a:t>M 1 div=10080 key=-1 time=3/4 clef=G2</a:t>
+            </a:r>
+            <a:endParaRPr lang="en-US" sz="700" dirty="0"/>
+          </a:p>
+        </p:txBody>
+      </p:sp>
+      <p:sp>
+        <p:nvSpPr>
+          <p:cNvPr id="31" name="Text 29"/>
+          <p:cNvSpPr/>
+          <p:nvPr/>
+        </p:nvSpPr>
+        <p:spPr>
+          <a:xfrm>
+            <a:off x="4746575" y="1843236"/>
+            <a:ext cx="4009314" cy="115491"/>
+          </a:xfrm>
+          <a:prstGeom prst="rect">
+            <a:avLst/>
+          </a:prstGeom>
+          <a:noFill/>
+          <a:ln/>
+        </p:spPr>
+        <p:txBody>
+          <a:bodyPr wrap="square" lIns="0" tIns="0" rIns="0" bIns="0" rtlCol="0" anchor="t"/>
+          <a:lstStyle/>
+          <a:p>
+            <a:pPr algn="l" indent="0" marL="0">
+              <a:lnSpc>
+                <a:spcPts val="910"/>
+              </a:lnSpc>
+              <a:buNone/>
+            </a:pPr>
+            <a:r>
+              <a:rPr lang="en-US" sz="700" dirty="0">
+                <a:solidFill>
+                  <a:srgbClr val="4421D2"/>
+                </a:solidFill>
+                <a:latin typeface="Courier New" pitchFamily="34" charset="0"/>
+                <a:ea typeface="Courier New" pitchFamily="34" charset="-122"/>
+                <a:cs typeface="Courier New" pitchFamily="34" charset="-120"/>
+              </a:rPr>
+              <a:t>dir @above [font-weight=bold] Andante</a:t>
+            </a:r>
+            <a:endParaRPr lang="en-US" sz="700" dirty="0"/>
+          </a:p>
+        </p:txBody>
+      </p:sp>
+      <p:sp>
+        <p:nvSpPr>
+          <p:cNvPr id="32" name="Text 30"/>
+          <p:cNvSpPr/>
+          <p:nvPr/>
+        </p:nvSpPr>
+        <p:spPr>
+          <a:xfrm>
+            <a:off x="4746575" y="1958727"/>
+            <a:ext cx="4009314" cy="115491"/>
+          </a:xfrm>
+          <a:prstGeom prst="rect">
+            <a:avLst/>
+          </a:prstGeom>
+          <a:noFill/>
+          <a:ln/>
+        </p:spPr>
+        <p:txBody>
+          <a:bodyPr wrap="square" lIns="0" tIns="0" rIns="0" bIns="0" rtlCol="0" anchor="t"/>
+          <a:lstStyle/>
+          <a:p>
+            <a:pPr algn="l" indent="0" marL="0">
+              <a:lnSpc>
+                <a:spcPts val="910"/>
+              </a:lnSpc>
+              <a:buNone/>
+            </a:pPr>
+            <a:r>
+              <a:rPr lang="en-US" sz="700" dirty="0">
+                <a:solidFill>
+                  <a:srgbClr val="4421D2"/>
+                </a:solidFill>
+                <a:latin typeface="Courier New" pitchFamily="34" charset="0"/>
+                <a:ea typeface="Courier New" pitchFamily="34" charset="-122"/>
+                <a:cs typeface="Courier New" pitchFamily="34" charset="-120"/>
+              </a:rPr>
+              <a:t>R whole 30240</a:t>
+            </a:r>
+            <a:endParaRPr lang="en-US" sz="700" dirty="0"/>
+          </a:p>
+        </p:txBody>
+      </p:sp>
+      <p:sp>
+        <p:nvSpPr>
+          <p:cNvPr id="33" name="Text 31"/>
+          <p:cNvSpPr/>
+          <p:nvPr/>
+        </p:nvSpPr>
+        <p:spPr>
+          <a:xfrm>
+            <a:off x="4746575" y="2074218"/>
+            <a:ext cx="4009314" cy="115491"/>
+          </a:xfrm>
+          <a:prstGeom prst="rect">
+            <a:avLst/>
+          </a:prstGeom>
+          <a:noFill/>
+          <a:ln/>
+        </p:spPr>
+        <p:txBody>
+          <a:bodyPr wrap="square" lIns="0" tIns="0" rIns="0" bIns="0" rtlCol="0" anchor="t"/>
+          <a:lstStyle/>
+          <a:p>
+            <a:pPr algn="l" indent="0" marL="0">
+              <a:lnSpc>
+                <a:spcPts val="910"/>
+              </a:lnSpc>
+              <a:buNone/>
+            </a:pPr>
+            <a:r>
+              <a:rPr lang="en-US" sz="700" dirty="0">
+                <a:solidFill>
+                  <a:srgbClr val="4421D2"/>
+                </a:solidFill>
+                <a:latin typeface="Courier New" pitchFamily="34" charset="0"/>
+                <a:ea typeface="Courier New" pitchFamily="34" charset="-122"/>
+                <a:cs typeface="Courier New" pitchFamily="34" charset="-120"/>
+              </a:rPr>
+              <a:t>M 6</a:t>
+            </a:r>
+            <a:endParaRPr lang="en-US" sz="700" dirty="0"/>
+          </a:p>
+        </p:txBody>
+      </p:sp>
+      <p:sp>
+        <p:nvSpPr>
+          <p:cNvPr id="34" name="Text 32"/>
+          <p:cNvSpPr/>
+          <p:nvPr/>
+        </p:nvSpPr>
+        <p:spPr>
+          <a:xfrm>
+            <a:off x="4746575" y="2189708"/>
+            <a:ext cx="4009314" cy="115491"/>
+          </a:xfrm>
+          <a:prstGeom prst="rect">
+            <a:avLst/>
+          </a:prstGeom>
+          <a:noFill/>
+          <a:ln/>
+        </p:spPr>
+        <p:txBody>
+          <a:bodyPr wrap="square" lIns="0" tIns="0" rIns="0" bIns="0" rtlCol="0" anchor="t"/>
+          <a:lstStyle/>
+          <a:p>
+            <a:pPr algn="l" indent="0" marL="0">
+              <a:lnSpc>
+                <a:spcPts val="910"/>
+              </a:lnSpc>
+              <a:buNone/>
+            </a:pPr>
+            <a:r>
+              <a:rPr lang="en-US" sz="700" b="1" dirty="0">
+                <a:solidFill>
+                  <a:srgbClr val="E41159"/>
+                </a:solidFill>
+                <a:latin typeface="Courier New" pitchFamily="34" charset="0"/>
+                <a:ea typeface="Courier New" pitchFamily="34" charset="-122"/>
+                <a:cs typeface="Courier New" pitchFamily="34" charset="-120"/>
+              </a:rPr>
+              <a:t>N C4 q 10080 su L1:s:Lord, L2:s:Let</a:t>
+            </a:r>
+            <a:endParaRPr lang="en-US" sz="700" dirty="0"/>
+          </a:p>
+        </p:txBody>
+      </p:sp>
+      <p:sp>
+        <p:nvSpPr>
+          <p:cNvPr id="35" name="Text 33"/>
+          <p:cNvSpPr/>
+          <p:nvPr/>
+        </p:nvSpPr>
+        <p:spPr>
+          <a:xfrm>
+            <a:off x="4746575" y="2305199"/>
+            <a:ext cx="4009314" cy="115491"/>
+          </a:xfrm>
+          <a:prstGeom prst="rect">
+            <a:avLst/>
+          </a:prstGeom>
+          <a:noFill/>
+          <a:ln/>
+        </p:spPr>
+        <p:txBody>
+          <a:bodyPr wrap="square" lIns="0" tIns="0" rIns="0" bIns="0" rtlCol="0" anchor="t"/>
+          <a:lstStyle/>
+          <a:p>
+            <a:pPr algn="l" indent="0" marL="0">
+              <a:lnSpc>
+                <a:spcPts val="910"/>
+              </a:lnSpc>
+              <a:buNone/>
+            </a:pPr>
+            <a:r>
+              <a:rPr lang="en-US" sz="700" b="1" dirty="0">
+                <a:solidFill>
+                  <a:srgbClr val="E41159"/>
+                </a:solidFill>
+                <a:latin typeface="Courier New" pitchFamily="34" charset="0"/>
+                <a:ea typeface="Courier New" pitchFamily="34" charset="-122"/>
+                <a:cs typeface="Courier New" pitchFamily="34" charset="-120"/>
+              </a:rPr>
+              <a:t>N Bn03 e 5040 acc=natural su L1:s:for</a:t>
+            </a:r>
+            <a:endParaRPr lang="en-US" sz="700" dirty="0"/>
+          </a:p>
+        </p:txBody>
+      </p:sp>
+      <p:sp>
+        <p:nvSpPr>
+          <p:cNvPr id="36" name="Text 34"/>
+          <p:cNvSpPr/>
+          <p:nvPr/>
+        </p:nvSpPr>
+        <p:spPr>
+          <a:xfrm>
+            <a:off x="4746575" y="2420689"/>
+            <a:ext cx="4009314" cy="115491"/>
+          </a:xfrm>
+          <a:prstGeom prst="rect">
+            <a:avLst/>
+          </a:prstGeom>
+          <a:noFill/>
+          <a:ln/>
+        </p:spPr>
+        <p:txBody>
+          <a:bodyPr wrap="square" lIns="0" tIns="0" rIns="0" bIns="0" rtlCol="0" anchor="t"/>
+          <a:lstStyle/>
+          <a:p>
+            <a:pPr algn="l" indent="0" marL="0">
+              <a:lnSpc>
+                <a:spcPts val="910"/>
+              </a:lnSpc>
+              <a:buNone/>
+            </a:pPr>
+            <a:r>
+              <a:rPr lang="en-US" sz="700" b="1" dirty="0">
+                <a:solidFill>
+                  <a:srgbClr val="E41159"/>
+                </a:solidFill>
+                <a:latin typeface="Courier New" pitchFamily="34" charset="0"/>
+                <a:ea typeface="Courier New" pitchFamily="34" charset="-122"/>
+                <a:cs typeface="Courier New" pitchFamily="34" charset="-120"/>
+              </a:rPr>
+              <a:t>N C4 e 5040 su L1:b:to L2:s:both</a:t>
+            </a:r>
+            <a:endParaRPr lang="en-US" sz="700" dirty="0"/>
+          </a:p>
+        </p:txBody>
+      </p:sp>
+      <p:sp>
+        <p:nvSpPr>
+          <p:cNvPr id="37" name="Text 35"/>
+          <p:cNvSpPr/>
+          <p:nvPr/>
+        </p:nvSpPr>
+        <p:spPr>
+          <a:xfrm>
+            <a:off x="4746575" y="2536180"/>
+            <a:ext cx="4009314" cy="115491"/>
+          </a:xfrm>
+          <a:prstGeom prst="rect">
+            <a:avLst/>
+          </a:prstGeom>
+          <a:noFill/>
+          <a:ln/>
+        </p:spPr>
+        <p:txBody>
+          <a:bodyPr wrap="square" lIns="0" tIns="0" rIns="0" bIns="0" rtlCol="0" anchor="t"/>
+          <a:lstStyle/>
+          <a:p>
+            <a:pPr algn="l" indent="0" marL="0">
+              <a:lnSpc>
+                <a:spcPts val="910"/>
+              </a:lnSpc>
+              <a:buNone/>
+            </a:pPr>
+            <a:r>
+              <a:rPr lang="en-US" sz="700" b="1" dirty="0">
+                <a:solidFill>
+                  <a:srgbClr val="E41159"/>
+                </a:solidFill>
+                <a:latin typeface="Courier New" pitchFamily="34" charset="0"/>
+                <a:ea typeface="Courier New" pitchFamily="34" charset="-122"/>
+                <a:cs typeface="Courier New" pitchFamily="34" charset="-120"/>
+              </a:rPr>
+              <a:t>N D4 e 5040 su L1:e:day L2:s:seek</a:t>
+            </a:r>
+            <a:endParaRPr lang="en-US" sz="700" dirty="0"/>
+          </a:p>
+        </p:txBody>
+      </p:sp>
+      <p:sp>
+        <p:nvSpPr>
+          <p:cNvPr id="38" name="Text 36"/>
+          <p:cNvSpPr/>
+          <p:nvPr/>
+        </p:nvSpPr>
+        <p:spPr>
+          <a:xfrm>
+            <a:off x="4746575" y="2651671"/>
+            <a:ext cx="4009314" cy="115491"/>
+          </a:xfrm>
+          <a:prstGeom prst="rect">
+            <a:avLst/>
+          </a:prstGeom>
+          <a:noFill/>
+          <a:ln/>
+        </p:spPr>
+        <p:txBody>
+          <a:bodyPr wrap="square" lIns="0" tIns="0" rIns="0" bIns="0" rtlCol="0" anchor="t"/>
+          <a:lstStyle/>
+          <a:p>
+            <a:pPr algn="l" indent="0" marL="0">
+              <a:lnSpc>
+                <a:spcPts val="910"/>
+              </a:lnSpc>
+              <a:buNone/>
+            </a:pPr>
+            <a:r>
+              <a:rPr lang="en-US" sz="700" dirty="0">
                 <a:solidFill>
                   <a:srgbClr val="110A29"/>
                 </a:solidFill>
-                <a:latin typeface="Arial" pitchFamily="34" charset="0"/>
-                <a:ea typeface="Arial" pitchFamily="34" charset="-122"/>
-                <a:cs typeface="Arial" pitchFamily="34" charset="-120"/>
-              </a:rPr>
-              <a:t> = quarter C4, stem up, lyric</a:t>
-            </a:r>
-            <a:endParaRPr lang="en-US" sz="1000" dirty="0"/>
-          </a:p>
-          <a:p>
-            <a:pPr algn="l" marL="114300" indent="-114300">
-              <a:spcAft>
-                <a:spcPts val="700"/>
-              </a:spcAft>
-              <a:buSzPct val="100000"/>
-              <a:buChar char="•"/>
-            </a:pPr>
-            <a:r>
-              <a:rPr lang="en-US" sz="1000" b="1" dirty="0">
+                <a:latin typeface="Courier New" pitchFamily="34" charset="0"/>
+                <a:ea typeface="Courier New" pitchFamily="34" charset="-122"/>
+                <a:cs typeface="Courier New" pitchFamily="34" charset="-120"/>
+              </a:rPr>
+              <a:t>... (actual notes with pitches and lyrics)</a:t>
+            </a:r>
+            <a:endParaRPr lang="en-US" sz="700" dirty="0"/>
+          </a:p>
+        </p:txBody>
+      </p:sp>
+      <p:sp>
+        <p:nvSpPr>
+          <p:cNvPr id="39" name="Text 37"/>
+          <p:cNvSpPr/>
+          <p:nvPr/>
+        </p:nvSpPr>
+        <p:spPr>
+          <a:xfrm>
+            <a:off x="4660850" y="2903637"/>
+            <a:ext cx="4184193" cy="228600"/>
+          </a:xfrm>
+          <a:prstGeom prst="rect">
+            <a:avLst/>
+          </a:prstGeom>
+          <a:noFill/>
+          <a:ln/>
+        </p:spPr>
+        <p:txBody>
+          <a:bodyPr wrap="square" lIns="0" tIns="0" rIns="0" bIns="0" rtlCol="0" anchor="t"/>
+          <a:lstStyle/>
+          <a:p>
+            <a:pPr algn="l" indent="0" marL="0">
+              <a:spcBef>
+                <a:spcPts val="400"/>
+              </a:spcBef>
+              <a:buNone/>
+            </a:pPr>
+            <a:r>
+              <a:rPr lang="en-US" sz="800" b="1" dirty="0">
                 <a:solidFill>
                   <a:srgbClr val="110A29"/>
                 </a:solidFill>
@@ -11764,16 +15235,16 @@
                 <a:ea typeface="Arial" pitchFamily="34" charset="-122"/>
                 <a:cs typeface="Arial" pitchFamily="34" charset="-120"/>
               </a:rPr>
-              <a:t>12x compression:</a:t>
+              <a:t>12x smaller.</a:t>
             </a:r>
             <a:pPr algn="l" indent="0" marL="0">
-              <a:spcAft>
-                <a:spcPts val="700"/>
-              </a:spcAft>
-              <a:buNone/>
-            </a:pPr>
-            <a:r>
-              <a:rPr lang="en-US" sz="1000" dirty="0">
+              <a:spcBef>
+                <a:spcPts val="400"/>
+              </a:spcBef>
+              <a:buNone/>
+            </a:pPr>
+            <a:r>
+              <a:rPr lang="en-US" sz="800" dirty="0">
                 <a:solidFill>
                   <a:srgbClr val="110A29"/>
                 </a:solidFill>
@@ -11781,235 +15252,15 @@
                 <a:ea typeface="Arial" pitchFamily="34" charset="-122"/>
                 <a:cs typeface="Arial" pitchFamily="34" charset="-120"/>
               </a:rPr>
-              <a:t> 14K tokens → 1.2K tokens</a:t>
-            </a:r>
-            <a:endParaRPr lang="en-US" sz="1000" dirty="0"/>
-          </a:p>
-          <a:p>
-            <a:pPr algn="l" marL="114300" indent="-114300">
-              <a:spcAft>
-                <a:spcPts val="700"/>
-              </a:spcAft>
-              <a:buSzPct val="100000"/>
-              <a:buChar char="•"/>
-            </a:pPr>
-            <a:r>
-              <a:rPr lang="en-US" sz="1000" dirty="0">
-                <a:solidFill>
-                  <a:srgbClr val="110A29"/>
-                </a:solidFill>
-                <a:latin typeface="Arial" pitchFamily="34" charset="0"/>
-                <a:ea typeface="Arial" pitchFamily="34" charset="-122"/>
-                <a:cs typeface="Arial" pitchFamily="34" charset="-120"/>
-              </a:rPr>
-              <a:t>99.2% lossless round-trip on 500 samples</a:t>
-            </a:r>
-            <a:endParaRPr lang="en-US" sz="1000" dirty="0"/>
-          </a:p>
-        </p:txBody>
-      </p:sp>
-      <p:sp>
-        <p:nvSpPr>
-          <p:cNvPr id="6" name="Text 4"/>
-          <p:cNvSpPr/>
-          <p:nvPr/>
-        </p:nvSpPr>
-        <p:spPr>
-          <a:xfrm>
-            <a:off x="4565600" y="962025"/>
-            <a:ext cx="12650" cy="4029075"/>
-          </a:xfrm>
-          <a:prstGeom prst="rect">
-            <a:avLst/>
-          </a:prstGeom>
-          <a:solidFill>
-            <a:srgbClr val="D9D5D2"/>
-          </a:solidFill>
-          <a:ln/>
-        </p:spPr>
-        <p:txBody>
-          <a:bodyPr wrap="square" rtlCol="0" anchor="ctr"/>
-          <a:lstStyle/>
-          <a:p>
-            <a:pPr indent="0" marL="0">
-              <a:buNone/>
-            </a:pPr>
-            <a:endParaRPr lang="en-US" dirty="0"/>
-          </a:p>
-        </p:txBody>
-      </p:sp>
-      <p:sp>
-        <p:nvSpPr>
-          <p:cNvPr id="7" name="Text 5"/>
-          <p:cNvSpPr/>
-          <p:nvPr/>
-        </p:nvSpPr>
-        <p:spPr>
-          <a:xfrm>
-            <a:off x="4832152" y="962025"/>
-            <a:ext cx="4009465" cy="209550"/>
-          </a:xfrm>
-          <a:prstGeom prst="rect">
-            <a:avLst/>
-          </a:prstGeom>
-          <a:noFill/>
-          <a:ln/>
-        </p:spPr>
-        <p:txBody>
-          <a:bodyPr wrap="square" lIns="0" tIns="0" rIns="0" bIns="0" rtlCol="0" anchor="t"/>
-          <a:lstStyle/>
-          <a:p>
-            <a:pPr algn="l" indent="0" marL="0">
-              <a:spcAft>
-                <a:spcPts val="1000"/>
-              </a:spcAft>
-              <a:buNone/>
-            </a:pPr>
-            <a:r>
-              <a:rPr lang="en-US" sz="1400" b="1" dirty="0">
-                <a:solidFill>
-                  <a:srgbClr val="E41159"/>
-                </a:solidFill>
-                <a:latin typeface="Arial" pitchFamily="34" charset="0"/>
-                <a:ea typeface="Arial" pitchFamily="34" charset="-122"/>
-                <a:cs typeface="Arial" pitchFamily="34" charset="-120"/>
-              </a:rPr>
-              <a:t>What It Preserves</a:t>
-            </a:r>
-            <a:endParaRPr lang="en-US" sz="1400" dirty="0"/>
-          </a:p>
-        </p:txBody>
-      </p:sp>
-      <p:sp>
-        <p:nvSpPr>
-          <p:cNvPr id="8" name="Text 6"/>
-          <p:cNvSpPr/>
-          <p:nvPr/>
-        </p:nvSpPr>
-        <p:spPr>
-          <a:xfrm>
-            <a:off x="4832152" y="1298525"/>
-            <a:ext cx="3930848" cy="1069777"/>
-          </a:xfrm>
-          <a:prstGeom prst="rect">
-            <a:avLst/>
-          </a:prstGeom>
-          <a:noFill/>
-          <a:ln/>
-        </p:spPr>
-        <p:txBody>
-          <a:bodyPr wrap="square" lIns="114300" tIns="0" rIns="0" bIns="0" rtlCol="0" anchor="t"/>
-          <a:lstStyle/>
-          <a:p>
-            <a:pPr algn="l" marL="114300" indent="-114300">
-              <a:spcAft>
-                <a:spcPts val="700"/>
-              </a:spcAft>
-              <a:buSzPct val="100000"/>
-              <a:buChar char="•"/>
-            </a:pPr>
-            <a:r>
-              <a:rPr lang="en-US" sz="1000" dirty="0">
-                <a:solidFill>
-                  <a:srgbClr val="110A29"/>
-                </a:solidFill>
-                <a:latin typeface="Arial" pitchFamily="34" charset="0"/>
-                <a:ea typeface="Arial" pitchFamily="34" charset="-122"/>
-                <a:cs typeface="Arial" pitchFamily="34" charset="-120"/>
-              </a:rPr>
-              <a:t>Pitches, durations, stems, beams</a:t>
-            </a:r>
-            <a:endParaRPr lang="en-US" sz="1000" dirty="0"/>
-          </a:p>
-          <a:p>
-            <a:pPr algn="l" marL="114300" indent="-114300">
-              <a:spcAft>
-                <a:spcPts val="700"/>
-              </a:spcAft>
-              <a:buSzPct val="100000"/>
-              <a:buChar char="•"/>
-            </a:pPr>
-            <a:r>
-              <a:rPr lang="en-US" sz="1000" dirty="0">
-                <a:solidFill>
-                  <a:srgbClr val="110A29"/>
-                </a:solidFill>
-                <a:latin typeface="Arial" pitchFamily="34" charset="0"/>
-                <a:ea typeface="Arial" pitchFamily="34" charset="-122"/>
-                <a:cs typeface="Arial" pitchFamily="34" charset="-120"/>
-              </a:rPr>
-              <a:t>Lyrics (bilingual, syllabic encoding)</a:t>
-            </a:r>
-            <a:endParaRPr lang="en-US" sz="1000" dirty="0"/>
-          </a:p>
-          <a:p>
-            <a:pPr algn="l" marL="114300" indent="-114300">
-              <a:spcAft>
-                <a:spcPts val="700"/>
-              </a:spcAft>
-              <a:buSzPct val="100000"/>
-              <a:buChar char="•"/>
-            </a:pPr>
-            <a:r>
-              <a:rPr lang="en-US" sz="1000" dirty="0">
-                <a:solidFill>
-                  <a:srgbClr val="110A29"/>
-                </a:solidFill>
-                <a:latin typeface="Arial" pitchFamily="34" charset="0"/>
-                <a:ea typeface="Arial" pitchFamily="34" charset="-122"/>
-                <a:cs typeface="Arial" pitchFamily="34" charset="-120"/>
-              </a:rPr>
-              <a:t>Key/time signatures, clefs</a:t>
-            </a:r>
-            <a:endParaRPr lang="en-US" sz="1000" dirty="0"/>
-          </a:p>
-          <a:p>
-            <a:pPr algn="l" marL="114300" indent="-114300">
-              <a:spcAft>
-                <a:spcPts val="700"/>
-              </a:spcAft>
-              <a:buSzPct val="100000"/>
-              <a:buChar char="•"/>
-            </a:pPr>
-            <a:r>
-              <a:rPr lang="en-US" sz="1000" dirty="0">
-                <a:solidFill>
-                  <a:srgbClr val="110A29"/>
-                </a:solidFill>
-                <a:latin typeface="Arial" pitchFamily="34" charset="0"/>
-                <a:ea typeface="Arial" pitchFamily="34" charset="-122"/>
-                <a:cs typeface="Arial" pitchFamily="34" charset="-120"/>
-              </a:rPr>
-              <a:t>Dynamics, directions, barlines</a:t>
-            </a:r>
-            <a:endParaRPr lang="en-US" sz="1000" dirty="0"/>
-          </a:p>
-          <a:p>
-            <a:pPr algn="l" marL="114300" indent="-114300">
-              <a:spcAft>
-                <a:spcPts val="700"/>
-              </a:spcAft>
-              <a:buSzPct val="100000"/>
-              <a:buChar char="•"/>
-            </a:pPr>
-            <a:r>
-              <a:rPr lang="en-US" sz="1000" dirty="0">
-                <a:solidFill>
-                  <a:srgbClr val="110A29"/>
-                </a:solidFill>
-                <a:latin typeface="Arial" pitchFamily="34" charset="0"/>
-                <a:ea typeface="Arial" pitchFamily="34" charset="-122"/>
-                <a:cs typeface="Arial" pitchFamily="34" charset="-120"/>
-              </a:rPr>
-              <a:t>Composer, lyricist, title</a:t>
-            </a:r>
-            <a:endParaRPr lang="en-US" sz="1000" dirty="0"/>
+              <a:t> Notes highlighted in pink are actual pitched content that the model can now learn from.</a:t>
+            </a:r>
+            <a:endParaRPr lang="en-US" sz="800" dirty="0"/>
           </a:p>
         </p:txBody>
       </p:sp>
       <p:pic>
         <p:nvPicPr>
-          <p:cNvPr id="9" name="Image 0" descr="/home/zsi/projects/worktrees/CVlization/vintage-music-sheet/examples/perception/optical_music_recognition/slides-omr-mxc/kungfu-logo.png">    </p:cNvPr>
+          <p:cNvPr id="40" name="Image 0" descr="/home/zsi/projects/worktrees/CVlization/vintage-music-sheet/examples/perception/optical_music_recognition/slides-omr-mxc/kungfu-logo.png">    </p:cNvPr>
           <p:cNvPicPr>
             <a:picLocks noChangeAspect="1"/>
           </p:cNvPicPr>

</xml_diff>

<commit_message>
Move slide images to zzsi/cvl HuggingFace; remove from git; update HTML to use HF URLs
</commit_message>
<xml_diff>
--- a/examples/perception/optical_music_recognition/slides-omr-mxc/omr-mxc-results.pptx
+++ b/examples/perception/optical_music_recognition/slides-omr-mxc/omr-mxc-results.pptx
@@ -10606,7 +10606,7 @@
       </p:sp>
       <p:pic>
         <p:nvPicPr>
-          <p:cNvPr id="8" name="Image 0" descr="/home/zsi/projects/worktrees/CVlization/vintage-music-sheet/examples/perception/optical_music_recognition/slides-omr-mxc/vintage_score_1884.jpg">    </p:cNvPr>
+          <p:cNvPr id="8" name="Image 0" descr="https://huggingface.co/datasets/zzsi/cvl/resolve/main/omr_slides/vintage_score_1884.jpg">    </p:cNvPr>
           <p:cNvPicPr>
             <a:picLocks noChangeAspect="1"/>
           </p:cNvPicPr>
@@ -11444,7 +11444,7 @@
       </p:sp>
       <p:pic>
         <p:nvPicPr>
-          <p:cNvPr id="6" name="Image 0" descr="/home/zsi/projects/worktrees/CVlization/vintage-music-sheet/examples/perception/optical_music_recognition/slides-omr-mxc/gemini3_rendered_ly.png">    </p:cNvPr>
+          <p:cNvPr id="6" name="Image 0" descr="https://huggingface.co/datasets/zzsi/cvl/resolve/main/omr_slides/gemini3_rendered_ly.png">    </p:cNvPr>
           <p:cNvPicPr>
             <a:picLocks noChangeAspect="1"/>
           </p:cNvPicPr>
@@ -11552,7 +11552,7 @@
       </p:sp>
       <p:pic>
         <p:nvPicPr>
-          <p:cNvPr id="9" name="Image 1" descr="/home/zsi/projects/worktrees/CVlization/vintage-music-sheet/examples/perception/optical_music_recognition/slides-omr-mxc/claude_opus_rendered_ly.png">    </p:cNvPr>
+          <p:cNvPr id="9" name="Image 1" descr="https://huggingface.co/datasets/zzsi/cvl/resolve/main/omr_slides/claude_opus_rendered_ly.png">    </p:cNvPr>
           <p:cNvPicPr>
             <a:picLocks noChangeAspect="1"/>
           </p:cNvPicPr>
@@ -11660,7 +11660,7 @@
       </p:sp>
       <p:pic>
         <p:nvPicPr>
-          <p:cNvPr id="12" name="Image 2" descr="/home/zsi/projects/worktrees/CVlization/vintage-music-sheet/examples/perception/optical_music_recognition/slides-omr-mxc/smt_omr_rendered_ly.png">    </p:cNvPr>
+          <p:cNvPr id="12" name="Image 2" descr="https://huggingface.co/datasets/zzsi/cvl/resolve/main/omr_slides/smt_omr_rendered_ly.png">    </p:cNvPr>
           <p:cNvPicPr>
             <a:picLocks noChangeAspect="1"/>
           </p:cNvPicPr>
@@ -11935,7 +11935,7 @@
       </p:sp>
       <p:pic>
         <p:nvPicPr>
-          <p:cNvPr id="6" name="Image 0" descr="/home/zsi/projects/worktrees/CVlization/vintage-music-sheet/examples/perception/optical_music_recognition/slides-omr-mxc/openscore_sample.png">    </p:cNvPr>
+          <p:cNvPr id="6" name="Image 0" descr="https://huggingface.co/datasets/zzsi/cvl/resolve/main/omr_slides/openscore_sample.png">    </p:cNvPr>
           <p:cNvPicPr>
             <a:picLocks noChangeAspect="1"/>
           </p:cNvPicPr>
@@ -12085,7 +12085,7 @@
       </p:sp>
       <p:pic>
         <p:nvPicPr>
-          <p:cNvPr id="10" name="Image 1" descr="/home/zsi/projects/worktrees/CVlization/vintage-music-sheet/examples/perception/optical_music_recognition/slides-omr-mxc/olimpic_sample.png">    </p:cNvPr>
+          <p:cNvPr id="10" name="Image 1" descr="https://huggingface.co/datasets/zzsi/cvl/resolve/main/omr_slides/olimpic_sample.png">    </p:cNvPr>
           <p:cNvPicPr>
             <a:picLocks noChangeAspect="1"/>
           </p:cNvPicPr>
@@ -13552,7 +13552,7 @@
       </p:sp>
       <p:pic>
         <p:nvPicPr>
-          <p:cNvPr id="12" name="Image 0" descr="/home/zsi/projects/worktrees/CVlization/vintage-music-sheet/examples/perception/optical_music_recognition/slides-omr-mxc/openscore_page1_example.png">    </p:cNvPr>
+          <p:cNvPr id="12" name="Image 0" descr="https://huggingface.co/datasets/zzsi/cvl/resolve/main/omr_slides/openscore_page1_example.png">    </p:cNvPr>
           <p:cNvPicPr>
             <a:picLocks noChangeAspect="1"/>
           </p:cNvPicPr>

</xml_diff>